<commit_message>
Ganti platform kuis dari Google Form ke Slido
</commit_message>
<xml_diff>
--- a/materi-pertemuan/pert1-code/pertemuan-1-web.pptx
+++ b/materi-pertemuan/pert1-code/pertemuan-1-web.pptx
@@ -17,6 +17,7 @@
     <p:sldId id="265" r:id="rId11"/>
     <p:sldId id="266" r:id="rId12"/>
     <p:sldId id="267" r:id="rId13"/>
+    <p:sldId id="268" r:id="rId14"/>
   </p:sldIdLst>
   <p:sldSz cx="12192000" cy="6858000"/>
   <p:notesSz cx="6858000" cy="9144000"/>
@@ -3515,6 +3516,36 @@
           </a:p>
         </p:txBody>
       </p:sp>
+      <p:pic>
+        <p:nvPicPr>
+          <p:cNvPr id="13" name="Picture 12">
+            <a:extLst>
+              <a:ext uri="{FF2B5EF4-FFF2-40B4-BE49-F238E27FC236}">
+                <a16:creationId xmlns:a16="http://schemas.microsoft.com/office/drawing/2014/main" id="{4C0E27FD-89E5-8541-CD1B-26527532576B}"/>
+              </a:ext>
+            </a:extLst>
+          </p:cNvPr>
+          <p:cNvPicPr>
+            <a:picLocks noChangeAspect="1"/>
+          </p:cNvPicPr>
+          <p:nvPr/>
+        </p:nvPicPr>
+        <p:blipFill>
+          <a:blip r:embed="rId2"/>
+          <a:stretch>
+            <a:fillRect/>
+          </a:stretch>
+        </p:blipFill>
+        <p:spPr>
+          <a:xfrm>
+            <a:off x="6723485" y="2807970"/>
+            <a:ext cx="4038600" cy="4038600"/>
+          </a:xfrm>
+          <a:prstGeom prst="rect">
+            <a:avLst/>
+          </a:prstGeom>
+        </p:spPr>
+      </p:pic>
     </p:spTree>
   </p:cSld>
   <p:clrMapOvr>
@@ -4533,8 +4564,8 @@
         </p:nvSpPr>
         <p:spPr>
           <a:xfrm>
-            <a:off x="640080" y="2194560"/>
-            <a:ext cx="10911535" cy="2743200"/>
+            <a:off x="640081" y="2194560"/>
+            <a:ext cx="10439400" cy="1036181"/>
           </a:xfrm>
           <a:prstGeom prst="rect">
             <a:avLst/>
@@ -4675,26 +4706,23 @@
                 </a:solidFill>
                 <a:latin typeface="Calibri"/>
               </a:rPr>
-              <a:t> HTML, </a:t>
-            </a:r>
-            <a:r>
-              <a:rPr sz="1600" dirty="0" err="1">
+              <a:t> HTML</a:t>
+            </a:r>
+            <a:r>
+              <a:rPr lang="en-US" sz="1600" dirty="0">
                 <a:solidFill>
                   <a:srgbClr val="33422B"/>
                 </a:solidFill>
                 <a:latin typeface="Calibri"/>
               </a:rPr>
-              <a:t>gra</a:t>
-            </a:r>
-            <a:r>
-              <a:rPr sz="1600" dirty="0">
-                <a:solidFill>
-                  <a:srgbClr val="33422B"/>
-                </a:solidFill>
-                <a:latin typeface="Calibri"/>
-              </a:rPr>
-              <a:t>…</a:t>
-            </a:r>
+              <a:t>.</a:t>
+            </a:r>
+            <a:endParaRPr sz="1600" dirty="0">
+              <a:solidFill>
+                <a:srgbClr val="33422B"/>
+              </a:solidFill>
+              <a:latin typeface="Calibri"/>
+            </a:endParaRPr>
           </a:p>
           <a:p>
             <a:pPr>
@@ -4816,8 +4844,23 @@
                 </a:solidFill>
                 <a:latin typeface="Calibri"/>
               </a:rPr>
-              <a:t> tab Extensions di…</a:t>
-            </a:r>
+              <a:t> tab Extensions</a:t>
+            </a:r>
+            <a:r>
+              <a:rPr lang="en-US" sz="1600" dirty="0">
+                <a:solidFill>
+                  <a:srgbClr val="33422B"/>
+                </a:solidFill>
+                <a:latin typeface="Calibri"/>
+              </a:rPr>
+              <a:t>.</a:t>
+            </a:r>
+            <a:endParaRPr sz="1600" dirty="0">
+              <a:solidFill>
+                <a:srgbClr val="33422B"/>
+              </a:solidFill>
+              <a:latin typeface="Calibri"/>
+            </a:endParaRPr>
           </a:p>
           <a:p>
             <a:pPr>
@@ -4912,26 +4955,23 @@
                 </a:solidFill>
                 <a:latin typeface="Calibri"/>
               </a:rPr>
-              <a:t> di Windows) — </a:t>
-            </a:r>
-            <a:r>
-              <a:rPr sz="1600" dirty="0" err="1">
+              <a:t> di Windows)</a:t>
+            </a:r>
+            <a:r>
+              <a:rPr lang="en-US" sz="1600" dirty="0">
                 <a:solidFill>
                   <a:srgbClr val="33422B"/>
                 </a:solidFill>
                 <a:latin typeface="Calibri"/>
               </a:rPr>
-              <a:t>buat</a:t>
-            </a:r>
-            <a:r>
-              <a:rPr sz="1600" dirty="0">
-                <a:solidFill>
-                  <a:srgbClr val="33422B"/>
-                </a:solidFill>
-                <a:latin typeface="Calibri"/>
-              </a:rPr>
-              <a:t> me…</a:t>
-            </a:r>
+              <a:t>.</a:t>
+            </a:r>
+            <a:endParaRPr sz="1600" dirty="0">
+              <a:solidFill>
+                <a:srgbClr val="33422B"/>
+              </a:solidFill>
+              <a:latin typeface="Calibri"/>
+            </a:endParaRPr>
           </a:p>
         </p:txBody>
       </p:sp>
@@ -5918,6 +5958,131 @@
 </p:sld>
 </file>
 
+<file path=ppt/slides/slide13.xml><?xml version="1.0" encoding="utf-8"?>
+<p:sld xmlns:a="http://schemas.openxmlformats.org/drawingml/2006/main" xmlns:r="http://schemas.openxmlformats.org/officeDocument/2006/relationships" xmlns:p="http://schemas.openxmlformats.org/presentationml/2006/main">
+  <p:cSld>
+    <p:bg>
+      <p:bgPr>
+        <a:blipFill>
+          <a:blip r:embed="rId2"/>
+          <a:tile tx="0" ty="0" sx="100000" sy="100000" flip="none" algn="tl"/>
+        </a:blipFill>
+        <a:effectLst/>
+      </p:bgPr>
+    </p:bg>
+    <p:spTree>
+      <p:nvGrpSpPr>
+        <p:cNvPr id="1" name=""/>
+        <p:cNvGrpSpPr/>
+        <p:nvPr/>
+      </p:nvGrpSpPr>
+      <p:grpSpPr>
+        <a:xfrm>
+          <a:off x="0" y="0"/>
+          <a:ext cx="0" cy="0"/>
+          <a:chOff x="0" y="0"/>
+          <a:chExt cx="0" cy="0"/>
+        </a:xfrm>
+      </p:grpSpPr>
+      <p:pic>
+        <p:nvPicPr>
+          <p:cNvPr id="3" name="Picture 2">
+            <a:extLst>
+              <a:ext uri="{FF2B5EF4-FFF2-40B4-BE49-F238E27FC236}">
+                <a16:creationId xmlns:a16="http://schemas.microsoft.com/office/drawing/2014/main" id="{5E73E8EE-17F6-0775-7CFE-D32B65C902AB}"/>
+              </a:ext>
+            </a:extLst>
+          </p:cNvPr>
+          <p:cNvPicPr>
+            <a:picLocks noChangeAspect="1"/>
+          </p:cNvPicPr>
+          <p:nvPr/>
+        </p:nvPicPr>
+        <p:blipFill>
+          <a:blip r:embed="rId3"/>
+          <a:stretch>
+            <a:fillRect/>
+          </a:stretch>
+        </p:blipFill>
+        <p:spPr>
+          <a:xfrm>
+            <a:off x="678426" y="759990"/>
+            <a:ext cx="10835148" cy="6098010"/>
+          </a:xfrm>
+          <a:prstGeom prst="rect">
+            <a:avLst/>
+          </a:prstGeom>
+        </p:spPr>
+      </p:pic>
+      <p:sp>
+        <p:nvSpPr>
+          <p:cNvPr id="4" name="Rectangle 3">
+            <a:extLst>
+              <a:ext uri="{FF2B5EF4-FFF2-40B4-BE49-F238E27FC236}">
+                <a16:creationId xmlns:a16="http://schemas.microsoft.com/office/drawing/2014/main" id="{8041BDA0-744C-D96E-C81F-9B2AF06802A4}"/>
+              </a:ext>
+            </a:extLst>
+          </p:cNvPr>
+          <p:cNvSpPr/>
+          <p:nvPr/>
+        </p:nvSpPr>
+        <p:spPr>
+          <a:xfrm>
+            <a:off x="4213118" y="4534474"/>
+            <a:ext cx="6228739" cy="923330"/>
+          </a:xfrm>
+          <a:prstGeom prst="rect">
+            <a:avLst/>
+          </a:prstGeom>
+          <a:noFill/>
+        </p:spPr>
+        <p:txBody>
+          <a:bodyPr wrap="square" lIns="91440" tIns="45720" rIns="91440" bIns="45720">
+            <a:spAutoFit/>
+          </a:bodyPr>
+          <a:lstStyle/>
+          <a:p>
+            <a:pPr algn="ctr"/>
+            <a:r>
+              <a:rPr lang="en-US" sz="5400" b="1" dirty="0">
+                <a:ln w="22225">
+                  <a:solidFill>
+                    <a:schemeClr val="accent2"/>
+                  </a:solidFill>
+                  <a:prstDash val="solid"/>
+                </a:ln>
+                <a:solidFill>
+                  <a:schemeClr val="accent2">
+                    <a:lumMod val="40000"/>
+                    <a:lumOff val="60000"/>
+                  </a:schemeClr>
+                </a:solidFill>
+                <a:effectLst>
+                  <a:outerShdw blurRad="50800" dist="38100" dir="10800000" algn="r" rotWithShape="0">
+                    <a:prstClr val="black">
+                      <a:alpha val="40000"/>
+                    </a:prstClr>
+                  </a:outerShdw>
+                </a:effectLst>
+              </a:rPr>
+              <a:t>Thank You &lt;3</a:t>
+            </a:r>
+          </a:p>
+        </p:txBody>
+      </p:sp>
+    </p:spTree>
+    <p:extLst>
+      <p:ext uri="{BB962C8B-B14F-4D97-AF65-F5344CB8AC3E}">
+        <p14:creationId xmlns:p14="http://schemas.microsoft.com/office/powerpoint/2010/main" val="2536704684"/>
+      </p:ext>
+    </p:extLst>
+  </p:cSld>
+  <p:clrMapOvr>
+    <a:masterClrMapping/>
+  </p:clrMapOvr>
+</p:sld>
+</file>
+
 <file path=ppt/slides/slide2.xml><?xml version="1.0" encoding="utf-8"?>
 <p:sld xmlns:a="http://schemas.openxmlformats.org/drawingml/2006/main" xmlns:r="http://schemas.openxmlformats.org/officeDocument/2006/relationships" xmlns:p="http://schemas.openxmlformats.org/presentationml/2006/main">
   <p:cSld>

</xml_diff>

<commit_message>
Tambah rekomendasi ekstensi VS Code di README
</commit_message>
<xml_diff>
--- a/materi-pertemuan/pert1-code/pertemuan-1-web.pptx
+++ b/materi-pertemuan/pert1-code/pertemuan-1-web.pptx
@@ -11,13 +11,14 @@
     <p:sldId id="259" r:id="rId5"/>
     <p:sldId id="260" r:id="rId6"/>
     <p:sldId id="261" r:id="rId7"/>
-    <p:sldId id="262" r:id="rId8"/>
-    <p:sldId id="263" r:id="rId9"/>
-    <p:sldId id="264" r:id="rId10"/>
-    <p:sldId id="265" r:id="rId11"/>
-    <p:sldId id="266" r:id="rId12"/>
-    <p:sldId id="267" r:id="rId13"/>
-    <p:sldId id="268" r:id="rId14"/>
+    <p:sldId id="269" r:id="rId8"/>
+    <p:sldId id="262" r:id="rId9"/>
+    <p:sldId id="263" r:id="rId10"/>
+    <p:sldId id="264" r:id="rId11"/>
+    <p:sldId id="265" r:id="rId12"/>
+    <p:sldId id="266" r:id="rId13"/>
+    <p:sldId id="267" r:id="rId14"/>
+    <p:sldId id="268" r:id="rId15"/>
   </p:sldIdLst>
   <p:sldSz cx="12192000" cy="6858000"/>
   <p:notesSz cx="6858000" cy="9144000"/>
@@ -3724,7 +3725,7 @@
                 </a:solidFill>
                 <a:latin typeface="Poppins"/>
               </a:rPr>
-              <a:t>Form: mengumpulkan input dari pengguna</a:t>
+              <a:t>Tag umum untuk isi konten</a:t>
             </a:r>
           </a:p>
         </p:txBody>
@@ -3783,40 +3784,6 @@
         <p:spPr>
           <a:xfrm>
             <a:off x="640080" y="1417320"/>
-            <a:ext cx="6766560" cy="914400"/>
-          </a:xfrm>
-          <a:prstGeom prst="rect">
-            <a:avLst/>
-          </a:prstGeom>
-          <a:noFill/>
-        </p:spPr>
-        <p:txBody>
-          <a:bodyPr wrap="square">
-            <a:spAutoFit/>
-          </a:bodyPr>
-          <a:lstStyle/>
-          <a:p>
-            <a:r>
-              <a:rPr sz="1700" i="0">
-                <a:solidFill>
-                  <a:srgbClr val="33422B"/>
-                </a:solidFill>
-                <a:latin typeface="Calibri"/>
-              </a:rPr>
-              <a:t>Form dipakai saat pengguna perlu mengetik atau memilih sesuatu, misalnya form kontak atau form login (dipakai lagi di pertemuan 5).</a:t>
-            </a:r>
-          </a:p>
-        </p:txBody>
-      </p:sp>
-      <p:sp>
-        <p:nvSpPr>
-          <p:cNvPr id="8" name="TextBox 7"/>
-          <p:cNvSpPr txBox="1"/>
-          <p:nvPr/>
-        </p:nvSpPr>
-        <p:spPr>
-          <a:xfrm>
-            <a:off x="640080" y="2194560"/>
             <a:ext cx="6766560" cy="2743200"/>
           </a:xfrm>
           <a:prstGeom prst="rect">
@@ -3850,7 +3817,7 @@
                 </a:solidFill>
                 <a:latin typeface="Calibri"/>
               </a:rPr>
-              <a:t>&lt;label&gt; — teks penjelas untuk input, for harus sama dengan id input agar saling terhubung (klik lab…</a:t>
+              <a:t>Heading: &lt;h1&gt; sampai &lt;h6&gt; — judul dan sub-judul, urut dari paling penting (h1) ke paling kecil.</a:t>
             </a:r>
           </a:p>
           <a:p>
@@ -3874,7 +3841,7 @@
                 </a:solidFill>
                 <a:latin typeface="Calibri"/>
               </a:rPr>
-              <a:t>&lt;input type="text"&gt; — kotak isian satu baris.</a:t>
+              <a:t>Paragraf: &lt;p&gt; — teks biasa.</a:t>
             </a:r>
           </a:p>
           <a:p>
@@ -3898,7 +3865,7 @@
                 </a:solidFill>
                 <a:latin typeface="Calibri"/>
               </a:rPr>
-              <a:t>&lt;textarea&gt; — kotak isian banyak baris.</a:t>
+              <a:t>List: &lt;ul&gt; (list tanpa urutan) dan &lt;ol&gt; (list berurutan), isinya &lt;li&gt; per item.</a:t>
             </a:r>
           </a:p>
           <a:p>
@@ -3922,20 +3889,44 @@
                 </a:solidFill>
                 <a:latin typeface="Calibri"/>
               </a:rPr>
-              <a:t>&lt;button type="submit"&gt; — tombol untuk mengirim form. Belum berfungsi mengirim data ke mana pun samp…</a:t>
-            </a:r>
-          </a:p>
-        </p:txBody>
-      </p:sp>
-      <p:sp>
-        <p:nvSpPr>
-          <p:cNvPr id="9" name="Rounded Rectangle 8"/>
+              <a:t>Gambar: &lt;img src="alamat-gambar.jpg" alt="deskripsi gambar"&gt;.</a:t>
+            </a:r>
+          </a:p>
+          <a:p>
+            <a:pPr>
+              <a:spcAft>
+                <a:spcPts val="800"/>
+              </a:spcAft>
+            </a:pPr>
+            <a:r>
+              <a:rPr sz="1600" b="1">
+                <a:solidFill>
+                  <a:srgbClr val="7C9473"/>
+                </a:solidFill>
+              </a:rPr>
+              <a:t>●  </a:t>
+            </a:r>
+            <a:r>
+              <a:rPr sz="1600">
+                <a:solidFill>
+                  <a:srgbClr val="33422B"/>
+                </a:solidFill>
+                <a:latin typeface="Calibri"/>
+              </a:rPr>
+              <a:t>Link: &lt;a href="alamat-tujuan"&gt;teks link&lt;/a&gt;.</a:t>
+            </a:r>
+          </a:p>
+        </p:txBody>
+      </p:sp>
+      <p:sp>
+        <p:nvSpPr>
+          <p:cNvPr id="8" name="Rounded Rectangle 7"/>
           <p:cNvSpPr/>
           <p:nvPr/>
         </p:nvSpPr>
         <p:spPr>
           <a:xfrm>
-            <a:off x="7406640" y="1417320"/>
+            <a:off x="7406640" y="1374648"/>
             <a:ext cx="4480560" cy="2194559"/>
           </a:xfrm>
           <a:prstGeom prst="roundRect">
@@ -3976,10 +3967,17 @@
                 </a:solidFill>
                 <a:latin typeface="Consolas"/>
               </a:rPr>
-              <a:t>&lt;form&gt;</a:t>
-            </a:r>
-          </a:p>
-          <a:p>
+              <a:t>&lt;h1&gt;</a:t>
+            </a:r>
+            <a:r>
+              <a:rPr sz="1300" dirty="0" err="1">
+                <a:solidFill>
+                  <a:srgbClr val="DCEFD1"/>
+                </a:solidFill>
+                <a:latin typeface="Consolas"/>
+              </a:rPr>
+              <a:t>Katalog</a:t>
+            </a:r>
             <a:r>
               <a:rPr sz="1300" dirty="0">
                 <a:solidFill>
@@ -3987,7 +3985,7 @@
                 </a:solidFill>
                 <a:latin typeface="Consolas"/>
               </a:rPr>
-              <a:t>&lt;label for="nama"&gt;Nama&lt;/label&gt;</a:t>
+              <a:t> UMKM Karawang&lt;/h1&gt;</a:t>
             </a:r>
           </a:p>
           <a:p>
@@ -3998,7 +3996,7 @@
                 </a:solidFill>
                 <a:latin typeface="Consolas"/>
               </a:rPr>
-              <a:t>&lt;input type="text" id="nama" name="nama" placeholder="Nama </a:t>
+              <a:t>&lt;p&gt;</a:t>
             </a:r>
             <a:r>
               <a:rPr sz="1300" dirty="0" err="1">
@@ -4007,7 +4005,7 @@
                 </a:solidFill>
                 <a:latin typeface="Consolas"/>
               </a:rPr>
-              <a:t>kamu</a:t>
+              <a:t>Temukan</a:t>
             </a:r>
             <a:r>
               <a:rPr sz="1300" dirty="0">
@@ -4016,10 +4014,17 @@
                 </a:solidFill>
                 <a:latin typeface="Consolas"/>
               </a:rPr>
-              <a:t>"&gt;</a:t>
-            </a:r>
-          </a:p>
-          <a:p>
+              <a:t> </a:t>
+            </a:r>
+            <a:r>
+              <a:rPr sz="1300" dirty="0" err="1">
+                <a:solidFill>
+                  <a:srgbClr val="DCEFD1"/>
+                </a:solidFill>
+                <a:latin typeface="Consolas"/>
+              </a:rPr>
+              <a:t>usaha</a:t>
+            </a:r>
             <a:r>
               <a:rPr sz="1300" dirty="0">
                 <a:solidFill>
@@ -4027,7 +4032,7 @@
                 </a:solidFill>
                 <a:latin typeface="Consolas"/>
               </a:rPr>
-              <a:t>&lt;label for="</a:t>
+              <a:t> </a:t>
             </a:r>
             <a:r>
               <a:rPr sz="1300" dirty="0" err="1">
@@ -4036,7 +4041,7 @@
                 </a:solidFill>
                 <a:latin typeface="Consolas"/>
               </a:rPr>
-              <a:t>pesan</a:t>
+              <a:t>lokal</a:t>
             </a:r>
             <a:r>
               <a:rPr sz="1300" dirty="0">
@@ -4045,7 +4050,7 @@
                 </a:solidFill>
                 <a:latin typeface="Consolas"/>
               </a:rPr>
-              <a:t>"&gt;</a:t>
+              <a:t> </a:t>
             </a:r>
             <a:r>
               <a:rPr sz="1300" dirty="0" err="1">
@@ -4054,7 +4059,7 @@
                 </a:solidFill>
                 <a:latin typeface="Consolas"/>
               </a:rPr>
-              <a:t>Pesan</a:t>
+              <a:t>terbaik</a:t>
             </a:r>
             <a:r>
               <a:rPr sz="1300" dirty="0">
@@ -4063,7 +4068,7 @@
                 </a:solidFill>
                 <a:latin typeface="Consolas"/>
               </a:rPr>
-              <a:t>&lt;/label&gt;</a:t>
+              <a:t> di Karawang.&lt;/p&gt;</a:t>
             </a:r>
           </a:p>
           <a:p>
@@ -4074,7 +4079,18 @@
                 </a:solidFill>
                 <a:latin typeface="Consolas"/>
               </a:rPr>
-              <a:t>&lt;</a:t>
+              <a:t>&lt;ul&gt;</a:t>
+            </a:r>
+          </a:p>
+          <a:p>
+            <a:r>
+              <a:rPr sz="1300" dirty="0">
+                <a:solidFill>
+                  <a:srgbClr val="DCEFD1"/>
+                </a:solidFill>
+                <a:latin typeface="Consolas"/>
+              </a:rPr>
+              <a:t>&lt;li&gt;</a:t>
             </a:r>
             <a:r>
               <a:rPr sz="1300" dirty="0" err="1">
@@ -4083,7 +4099,7 @@
                 </a:solidFill>
                 <a:latin typeface="Consolas"/>
               </a:rPr>
-              <a:t>textarea</a:t>
+              <a:t>Kuliner</a:t>
             </a:r>
             <a:r>
               <a:rPr sz="1300" dirty="0">
@@ -4092,7 +4108,29 @@
                 </a:solidFill>
                 <a:latin typeface="Consolas"/>
               </a:rPr>
-              <a:t> id="</a:t>
+              <a:t>&lt;/li&gt;</a:t>
+            </a:r>
+          </a:p>
+          <a:p>
+            <a:r>
+              <a:rPr sz="1300" dirty="0">
+                <a:solidFill>
+                  <a:srgbClr val="DCEFD1"/>
+                </a:solidFill>
+                <a:latin typeface="Consolas"/>
+              </a:rPr>
+              <a:t>&lt;li&gt;Fashion&lt;/li&gt;</a:t>
+            </a:r>
+          </a:p>
+          <a:p>
+            <a:r>
+              <a:rPr sz="1300" dirty="0">
+                <a:solidFill>
+                  <a:srgbClr val="DCEFD1"/>
+                </a:solidFill>
+                <a:latin typeface="Consolas"/>
+              </a:rPr>
+              <a:t>&lt;li&gt;</a:t>
             </a:r>
             <a:r>
               <a:rPr sz="1300" dirty="0" err="1">
@@ -4101,7 +4139,7 @@
                 </a:solidFill>
                 <a:latin typeface="Consolas"/>
               </a:rPr>
-              <a:t>pesan</a:t>
+              <a:t>Kerajinan</a:t>
             </a:r>
             <a:r>
               <a:rPr sz="1300" dirty="0">
@@ -4110,79 +4148,14 @@
                 </a:solidFill>
                 <a:latin typeface="Consolas"/>
               </a:rPr>
-              <a:t>" name="</a:t>
-            </a:r>
-            <a:r>
-              <a:rPr sz="1300" dirty="0" err="1">
-                <a:solidFill>
-                  <a:srgbClr val="DCEFD1"/>
-                </a:solidFill>
-                <a:latin typeface="Consolas"/>
-              </a:rPr>
-              <a:t>pesan</a:t>
-            </a:r>
-            <a:r>
-              <a:rPr sz="1300" dirty="0">
-                <a:solidFill>
-                  <a:srgbClr val="DCEFD1"/>
-                </a:solidFill>
-                <a:latin typeface="Consolas"/>
-              </a:rPr>
-              <a:t>" placeholder="Tulis </a:t>
-            </a:r>
-            <a:r>
-              <a:rPr sz="1300" dirty="0" err="1">
-                <a:solidFill>
-                  <a:srgbClr val="DCEFD1"/>
-                </a:solidFill>
-                <a:latin typeface="Consolas"/>
-              </a:rPr>
-              <a:t>pesan</a:t>
-            </a:r>
-            <a:r>
-              <a:rPr sz="1300" dirty="0">
-                <a:solidFill>
-                  <a:srgbClr val="DCEFD1"/>
-                </a:solidFill>
-                <a:latin typeface="Consolas"/>
-              </a:rPr>
-              <a:t>..."&gt;&lt;/</a:t>
-            </a:r>
-            <a:r>
-              <a:rPr sz="1300" dirty="0" err="1">
-                <a:solidFill>
-                  <a:srgbClr val="DCEFD1"/>
-                </a:solidFill>
-                <a:latin typeface="Consolas"/>
-              </a:rPr>
-              <a:t>textarea</a:t>
-            </a:r>
-            <a:r>
-              <a:rPr sz="1300" dirty="0">
-                <a:solidFill>
-                  <a:srgbClr val="DCEFD1"/>
-                </a:solidFill>
-                <a:latin typeface="Consolas"/>
-              </a:rPr>
-              <a:t>&gt;</a:t>
-            </a:r>
-          </a:p>
-          <a:p>
-            <a:r>
-              <a:rPr sz="1300" dirty="0">
-                <a:solidFill>
-                  <a:srgbClr val="DCEFD1"/>
-                </a:solidFill>
-                <a:latin typeface="Consolas"/>
-              </a:rPr>
-              <a:t>&lt;button type="submit"&gt;Kirim&lt;/button&gt;</a:t>
-            </a:r>
-          </a:p>
-        </p:txBody>
-      </p:sp>
-      <p:sp>
-        <p:nvSpPr>
-          <p:cNvPr id="10" name="Rectangle 9"/>
+              <a:t>&lt;/li&gt;</a:t>
+            </a:r>
+          </a:p>
+        </p:txBody>
+      </p:sp>
+      <p:sp>
+        <p:nvSpPr>
+          <p:cNvPr id="9" name="Rectangle 8"/>
           <p:cNvSpPr/>
           <p:nvPr/>
         </p:nvSpPr>
@@ -4227,7 +4200,7 @@
       </p:sp>
       <p:sp>
         <p:nvSpPr>
-          <p:cNvPr id="11" name="TextBox 10"/>
+          <p:cNvPr id="10" name="TextBox 9"/>
           <p:cNvSpPr txBox="1"/>
           <p:nvPr/>
         </p:nvSpPr>
@@ -4261,7 +4234,7 @@
       </p:sp>
       <p:sp>
         <p:nvSpPr>
-          <p:cNvPr id="12" name="TextBox 11"/>
+          <p:cNvPr id="11" name="TextBox 10"/>
           <p:cNvSpPr txBox="1"/>
           <p:nvPr/>
         </p:nvSpPr>
@@ -4289,7 +4262,7 @@
                 </a:solidFill>
                 <a:latin typeface="Calibri"/>
               </a:rPr>
-              <a:t>9</a:t>
+              <a:t>8</a:t>
             </a:r>
           </a:p>
         </p:txBody>
@@ -4472,7 +4445,7 @@
                 </a:solidFill>
                 <a:latin typeface="Poppins"/>
               </a:rPr>
-              <a:t>Tools yang Dibutuhkan Hari Ini</a:t>
+              <a:t>Form: mengumpulkan input dari pengguna</a:t>
             </a:r>
           </a:p>
         </p:txBody>
@@ -4531,7 +4504,7 @@
         <p:spPr>
           <a:xfrm>
             <a:off x="640080" y="1417320"/>
-            <a:ext cx="10911535" cy="914400"/>
+            <a:ext cx="6766560" cy="914400"/>
           </a:xfrm>
           <a:prstGeom prst="rect">
             <a:avLst/>
@@ -4551,7 +4524,7 @@
                 </a:solidFill>
                 <a:latin typeface="Calibri"/>
               </a:rPr>
-              <a:t>Sebelum mulai ngoding, siapkan tiga hal ini dulu di laptop kamu.</a:t>
+              <a:t>Form dipakai saat pengguna perlu mengetik atau memilih sesuatu, misalnya form kontak atau form login (dipakai lagi di pertemuan 5).</a:t>
             </a:r>
           </a:p>
         </p:txBody>
@@ -4564,8 +4537,8 @@
         </p:nvSpPr>
         <p:spPr>
           <a:xfrm>
-            <a:off x="640081" y="2194560"/>
-            <a:ext cx="10439400" cy="1036181"/>
+            <a:off x="640080" y="2194560"/>
+            <a:ext cx="6766560" cy="2743200"/>
           </a:xfrm>
           <a:prstGeom prst="rect">
             <a:avLst/>
@@ -4584,7 +4557,7 @@
               </a:spcAft>
             </a:pPr>
             <a:r>
-              <a:rPr sz="1600" b="1" dirty="0">
+              <a:rPr sz="1600" b="1">
                 <a:solidFill>
                   <a:srgbClr val="7C9473"/>
                 </a:solidFill>
@@ -4592,137 +4565,14 @@
               <a:t>●  </a:t>
             </a:r>
             <a:r>
-              <a:rPr sz="1600" dirty="0">
+              <a:rPr sz="1600">
                 <a:solidFill>
                   <a:srgbClr val="33422B"/>
                 </a:solidFill>
                 <a:latin typeface="Calibri"/>
               </a:rPr>
-              <a:t>VS Code — </a:t>
-            </a:r>
-            <a:r>
-              <a:rPr sz="1600" dirty="0" err="1">
-                <a:solidFill>
-                  <a:srgbClr val="33422B"/>
-                </a:solidFill>
-                <a:latin typeface="Calibri"/>
-              </a:rPr>
-              <a:t>unduh</a:t>
-            </a:r>
-            <a:r>
-              <a:rPr sz="1600" dirty="0">
-                <a:solidFill>
-                  <a:srgbClr val="33422B"/>
-                </a:solidFill>
-                <a:latin typeface="Calibri"/>
-              </a:rPr>
-              <a:t> di code.visualstudio.com/Download — editor </a:t>
-            </a:r>
-            <a:r>
-              <a:rPr sz="1600" dirty="0" err="1">
-                <a:solidFill>
-                  <a:srgbClr val="33422B"/>
-                </a:solidFill>
-                <a:latin typeface="Calibri"/>
-              </a:rPr>
-              <a:t>tempat</a:t>
-            </a:r>
-            <a:r>
-              <a:rPr sz="1600" dirty="0">
-                <a:solidFill>
-                  <a:srgbClr val="33422B"/>
-                </a:solidFill>
-                <a:latin typeface="Calibri"/>
-              </a:rPr>
-              <a:t> </a:t>
-            </a:r>
-            <a:r>
-              <a:rPr sz="1600" dirty="0" err="1">
-                <a:solidFill>
-                  <a:srgbClr val="33422B"/>
-                </a:solidFill>
-                <a:latin typeface="Calibri"/>
-              </a:rPr>
-              <a:t>kita</a:t>
-            </a:r>
-            <a:r>
-              <a:rPr sz="1600" dirty="0">
-                <a:solidFill>
-                  <a:srgbClr val="33422B"/>
-                </a:solidFill>
-                <a:latin typeface="Calibri"/>
-              </a:rPr>
-              <a:t> </a:t>
-            </a:r>
-            <a:r>
-              <a:rPr sz="1600" dirty="0" err="1">
-                <a:solidFill>
-                  <a:srgbClr val="33422B"/>
-                </a:solidFill>
-                <a:latin typeface="Calibri"/>
-              </a:rPr>
-              <a:t>menulis</a:t>
-            </a:r>
-            <a:r>
-              <a:rPr sz="1600" dirty="0">
-                <a:solidFill>
-                  <a:srgbClr val="33422B"/>
-                </a:solidFill>
-                <a:latin typeface="Calibri"/>
-              </a:rPr>
-              <a:t> </a:t>
-            </a:r>
-            <a:r>
-              <a:rPr sz="1600" dirty="0" err="1">
-                <a:solidFill>
-                  <a:srgbClr val="33422B"/>
-                </a:solidFill>
-                <a:latin typeface="Calibri"/>
-              </a:rPr>
-              <a:t>semua</a:t>
-            </a:r>
-            <a:r>
-              <a:rPr sz="1600" dirty="0">
-                <a:solidFill>
-                  <a:srgbClr val="33422B"/>
-                </a:solidFill>
-                <a:latin typeface="Calibri"/>
-              </a:rPr>
-              <a:t> </a:t>
-            </a:r>
-            <a:r>
-              <a:rPr sz="1600" dirty="0" err="1">
-                <a:solidFill>
-                  <a:srgbClr val="33422B"/>
-                </a:solidFill>
-                <a:latin typeface="Calibri"/>
-              </a:rPr>
-              <a:t>kode</a:t>
-            </a:r>
-            <a:r>
-              <a:rPr sz="1600" dirty="0">
-                <a:solidFill>
-                  <a:srgbClr val="33422B"/>
-                </a:solidFill>
-                <a:latin typeface="Calibri"/>
-              </a:rPr>
-              <a:t> HTML</a:t>
-            </a:r>
-            <a:r>
-              <a:rPr lang="en-US" sz="1600" dirty="0">
-                <a:solidFill>
-                  <a:srgbClr val="33422B"/>
-                </a:solidFill>
-                <a:latin typeface="Calibri"/>
-              </a:rPr>
-              <a:t>.</a:t>
-            </a:r>
-            <a:endParaRPr sz="1600" dirty="0">
-              <a:solidFill>
-                <a:srgbClr val="33422B"/>
-              </a:solidFill>
-              <a:latin typeface="Calibri"/>
-            </a:endParaRPr>
+              <a:t>&lt;label&gt; — teks penjelas untuk input, for harus sama dengan id input agar saling terhubung (klik lab…</a:t>
+            </a:r>
           </a:p>
           <a:p>
             <a:pPr>
@@ -4731,7 +4581,7 @@
               </a:spcAft>
             </a:pPr>
             <a:r>
-              <a:rPr sz="1600" b="1" dirty="0">
+              <a:rPr sz="1600" b="1">
                 <a:solidFill>
                   <a:srgbClr val="7C9473"/>
                 </a:solidFill>
@@ -4739,128 +4589,14 @@
               <a:t>●  </a:t>
             </a:r>
             <a:r>
-              <a:rPr sz="1600" dirty="0" err="1">
+              <a:rPr sz="1600">
                 <a:solidFill>
                   <a:srgbClr val="33422B"/>
                 </a:solidFill>
                 <a:latin typeface="Calibri"/>
               </a:rPr>
-              <a:t>Ekstensi</a:t>
-            </a:r>
-            <a:r>
-              <a:rPr sz="1600" dirty="0">
-                <a:solidFill>
-                  <a:srgbClr val="33422B"/>
-                </a:solidFill>
-                <a:latin typeface="Calibri"/>
-              </a:rPr>
-              <a:t> Live Server — </a:t>
-            </a:r>
-            <a:r>
-              <a:rPr sz="1600" dirty="0" err="1">
-                <a:solidFill>
-                  <a:srgbClr val="33422B"/>
-                </a:solidFill>
-                <a:latin typeface="Calibri"/>
-              </a:rPr>
-              <a:t>cari</a:t>
-            </a:r>
-            <a:r>
-              <a:rPr sz="1600" dirty="0">
-                <a:solidFill>
-                  <a:srgbClr val="33422B"/>
-                </a:solidFill>
-                <a:latin typeface="Calibri"/>
-              </a:rPr>
-              <a:t> </a:t>
-            </a:r>
-            <a:r>
-              <a:rPr sz="1600" dirty="0" err="1">
-                <a:solidFill>
-                  <a:srgbClr val="33422B"/>
-                </a:solidFill>
-                <a:latin typeface="Calibri"/>
-              </a:rPr>
-              <a:t>lewat</a:t>
-            </a:r>
-            <a:r>
-              <a:rPr sz="1600" dirty="0">
-                <a:solidFill>
-                  <a:srgbClr val="33422B"/>
-                </a:solidFill>
-                <a:latin typeface="Calibri"/>
-              </a:rPr>
-              <a:t> marketplace.visualstudio.com </a:t>
-            </a:r>
-            <a:r>
-              <a:rPr sz="1600" dirty="0" err="1">
-                <a:solidFill>
-                  <a:srgbClr val="33422B"/>
-                </a:solidFill>
-                <a:latin typeface="Calibri"/>
-              </a:rPr>
-              <a:t>atau</a:t>
-            </a:r>
-            <a:r>
-              <a:rPr sz="1600" dirty="0">
-                <a:solidFill>
-                  <a:srgbClr val="33422B"/>
-                </a:solidFill>
-                <a:latin typeface="Calibri"/>
-              </a:rPr>
-              <a:t> </a:t>
-            </a:r>
-            <a:r>
-              <a:rPr sz="1600" dirty="0" err="1">
-                <a:solidFill>
-                  <a:srgbClr val="33422B"/>
-                </a:solidFill>
-                <a:latin typeface="Calibri"/>
-              </a:rPr>
-              <a:t>langsung</a:t>
-            </a:r>
-            <a:r>
-              <a:rPr sz="1600" dirty="0">
-                <a:solidFill>
-                  <a:srgbClr val="33422B"/>
-                </a:solidFill>
-                <a:latin typeface="Calibri"/>
-              </a:rPr>
-              <a:t> </a:t>
-            </a:r>
-            <a:r>
-              <a:rPr sz="1600" dirty="0" err="1">
-                <a:solidFill>
-                  <a:srgbClr val="33422B"/>
-                </a:solidFill>
-                <a:latin typeface="Calibri"/>
-              </a:rPr>
-              <a:t>dari</a:t>
-            </a:r>
-            <a:r>
-              <a:rPr sz="1600" dirty="0">
-                <a:solidFill>
-                  <a:srgbClr val="33422B"/>
-                </a:solidFill>
-                <a:latin typeface="Calibri"/>
-              </a:rPr>
-              <a:t> tab Extensions</a:t>
-            </a:r>
-            <a:r>
-              <a:rPr lang="en-US" sz="1600" dirty="0">
-                <a:solidFill>
-                  <a:srgbClr val="33422B"/>
-                </a:solidFill>
-                <a:latin typeface="Calibri"/>
-              </a:rPr>
-              <a:t>.</a:t>
-            </a:r>
-            <a:endParaRPr sz="1600" dirty="0">
-              <a:solidFill>
-                <a:srgbClr val="33422B"/>
-              </a:solidFill>
-              <a:latin typeface="Calibri"/>
-            </a:endParaRPr>
+              <a:t>&lt;input type="text"&gt; — kotak isian satu baris.</a:t>
+            </a:r>
           </a:p>
           <a:p>
             <a:pPr>
@@ -4869,7 +4605,7 @@
               </a:spcAft>
             </a:pPr>
             <a:r>
-              <a:rPr sz="1600" b="1" dirty="0">
+              <a:rPr sz="1600" b="1">
                 <a:solidFill>
                   <a:srgbClr val="7C9473"/>
                 </a:solidFill>
@@ -4877,134 +4613,290 @@
               <a:t>●  </a:t>
             </a:r>
             <a:r>
-              <a:rPr sz="1600" dirty="0">
+              <a:rPr sz="1600">
                 <a:solidFill>
                   <a:srgbClr val="33422B"/>
                 </a:solidFill>
                 <a:latin typeface="Calibri"/>
               </a:rPr>
-              <a:t>Browser modern — Chrome (google.com/chrome) </a:t>
-            </a:r>
-            <a:r>
-              <a:rPr sz="1600" dirty="0" err="1">
+              <a:t>&lt;textarea&gt; — kotak isian banyak baris.</a:t>
+            </a:r>
+          </a:p>
+          <a:p>
+            <a:pPr>
+              <a:spcAft>
+                <a:spcPts val="800"/>
+              </a:spcAft>
+            </a:pPr>
+            <a:r>
+              <a:rPr sz="1600" b="1">
+                <a:solidFill>
+                  <a:srgbClr val="7C9473"/>
+                </a:solidFill>
+              </a:rPr>
+              <a:t>●  </a:t>
+            </a:r>
+            <a:r>
+              <a:rPr sz="1600">
                 <a:solidFill>
                   <a:srgbClr val="33422B"/>
                 </a:solidFill>
                 <a:latin typeface="Calibri"/>
               </a:rPr>
-              <a:t>atau</a:t>
-            </a:r>
-            <a:r>
-              <a:rPr sz="1600" dirty="0">
-                <a:solidFill>
-                  <a:srgbClr val="33422B"/>
-                </a:solidFill>
-                <a:latin typeface="Calibri"/>
-              </a:rPr>
-              <a:t> Edge (</a:t>
-            </a:r>
-            <a:r>
-              <a:rPr sz="1600" dirty="0" err="1">
-                <a:solidFill>
-                  <a:srgbClr val="33422B"/>
-                </a:solidFill>
-                <a:latin typeface="Calibri"/>
-              </a:rPr>
-              <a:t>sudah</a:t>
-            </a:r>
-            <a:r>
-              <a:rPr sz="1600" dirty="0">
-                <a:solidFill>
-                  <a:srgbClr val="33422B"/>
-                </a:solidFill>
-                <a:latin typeface="Calibri"/>
-              </a:rPr>
-              <a:t> </a:t>
-            </a:r>
-            <a:r>
-              <a:rPr sz="1600" dirty="0" err="1">
-                <a:solidFill>
-                  <a:srgbClr val="33422B"/>
-                </a:solidFill>
-                <a:latin typeface="Calibri"/>
-              </a:rPr>
-              <a:t>terpasang</a:t>
-            </a:r>
-            <a:r>
-              <a:rPr sz="1600" dirty="0">
-                <a:solidFill>
-                  <a:srgbClr val="33422B"/>
-                </a:solidFill>
-                <a:latin typeface="Calibri"/>
-              </a:rPr>
-              <a:t> </a:t>
-            </a:r>
-            <a:r>
-              <a:rPr sz="1600" dirty="0" err="1">
-                <a:solidFill>
-                  <a:srgbClr val="33422B"/>
-                </a:solidFill>
-                <a:latin typeface="Calibri"/>
-              </a:rPr>
-              <a:t>bawaan</a:t>
-            </a:r>
-            <a:r>
-              <a:rPr sz="1600" dirty="0">
-                <a:solidFill>
-                  <a:srgbClr val="33422B"/>
-                </a:solidFill>
-                <a:latin typeface="Calibri"/>
-              </a:rPr>
-              <a:t> di Windows)</a:t>
-            </a:r>
-            <a:r>
-              <a:rPr lang="en-US" sz="1600" dirty="0">
-                <a:solidFill>
-                  <a:srgbClr val="33422B"/>
-                </a:solidFill>
-                <a:latin typeface="Calibri"/>
-              </a:rPr>
-              <a:t>.</a:t>
-            </a:r>
-            <a:endParaRPr sz="1600" dirty="0">
-              <a:solidFill>
-                <a:srgbClr val="33422B"/>
-              </a:solidFill>
-              <a:latin typeface="Calibri"/>
-            </a:endParaRPr>
-          </a:p>
-        </p:txBody>
-      </p:sp>
-      <p:sp>
-        <p:nvSpPr>
-          <p:cNvPr id="9" name="TextBox 8"/>
-          <p:cNvSpPr txBox="1"/>
-          <p:nvPr/>
-        </p:nvSpPr>
-        <p:spPr>
-          <a:xfrm>
-            <a:off x="640080" y="5989320"/>
-            <a:ext cx="10911535" cy="914400"/>
-          </a:xfrm>
-          <a:prstGeom prst="rect">
-            <a:avLst/>
-          </a:prstGeom>
-          <a:noFill/>
-        </p:spPr>
-        <p:txBody>
-          <a:bodyPr wrap="square">
-            <a:spAutoFit/>
-          </a:bodyPr>
-          <a:lstStyle/>
-          <a:p>
-            <a:r>
-              <a:rPr sz="1300" i="1">
-                <a:solidFill>
-                  <a:srgbClr val="5A6652"/>
-                </a:solidFill>
-                <a:latin typeface="Calibri"/>
-              </a:rPr>
-              <a:t>🖼  Tambahkan gambar: screenshot VS Code dengan panel Extensions terbuka, ekstensi Live Server ter-highlight.</a:t>
+              <a:t>&lt;button type="submit"&gt; — tombol untuk mengirim form. Belum berfungsi mengirim data ke mana pun samp…</a:t>
+            </a:r>
+          </a:p>
+        </p:txBody>
+      </p:sp>
+      <p:sp>
+        <p:nvSpPr>
+          <p:cNvPr id="9" name="Rounded Rectangle 8"/>
+          <p:cNvSpPr/>
+          <p:nvPr/>
+        </p:nvSpPr>
+        <p:spPr>
+          <a:xfrm>
+            <a:off x="7406640" y="1417320"/>
+            <a:ext cx="4480560" cy="2194559"/>
+          </a:xfrm>
+          <a:prstGeom prst="roundRect">
+            <a:avLst>
+              <a:gd name="adj" fmla="val 6000"/>
+            </a:avLst>
+          </a:prstGeom>
+          <a:solidFill>
+            <a:srgbClr val="22301C"/>
+          </a:solidFill>
+          <a:ln>
+            <a:noFill/>
+          </a:ln>
+          <a:effectLst/>
+        </p:spPr>
+        <p:style>
+          <a:lnRef idx="1">
+            <a:schemeClr val="accent1"/>
+          </a:lnRef>
+          <a:fillRef idx="3">
+            <a:schemeClr val="accent1"/>
+          </a:fillRef>
+          <a:effectRef idx="2">
+            <a:schemeClr val="accent1"/>
+          </a:effectRef>
+          <a:fontRef idx="minor">
+            <a:schemeClr val="lt1"/>
+          </a:fontRef>
+        </p:style>
+        <p:txBody>
+          <a:bodyPr wrap="square" lIns="182880" tIns="109728" rIns="137160" bIns="109728" rtlCol="0" anchor="ctr"/>
+          <a:lstStyle/>
+          <a:p>
+            <a:r>
+              <a:rPr sz="1300" dirty="0">
+                <a:solidFill>
+                  <a:srgbClr val="DCEFD1"/>
+                </a:solidFill>
+                <a:latin typeface="Consolas"/>
+              </a:rPr>
+              <a:t>&lt;form&gt;</a:t>
+            </a:r>
+          </a:p>
+          <a:p>
+            <a:r>
+              <a:rPr sz="1300" dirty="0">
+                <a:solidFill>
+                  <a:srgbClr val="DCEFD1"/>
+                </a:solidFill>
+                <a:latin typeface="Consolas"/>
+              </a:rPr>
+              <a:t>&lt;label for="nama"&gt;Nama&lt;/label&gt;</a:t>
+            </a:r>
+          </a:p>
+          <a:p>
+            <a:r>
+              <a:rPr sz="1300" dirty="0">
+                <a:solidFill>
+                  <a:srgbClr val="DCEFD1"/>
+                </a:solidFill>
+                <a:latin typeface="Consolas"/>
+              </a:rPr>
+              <a:t>&lt;input type="text" id="nama" name="nama" placeholder="Nama </a:t>
+            </a:r>
+            <a:r>
+              <a:rPr sz="1300" dirty="0" err="1">
+                <a:solidFill>
+                  <a:srgbClr val="DCEFD1"/>
+                </a:solidFill>
+                <a:latin typeface="Consolas"/>
+              </a:rPr>
+              <a:t>kamu</a:t>
+            </a:r>
+            <a:r>
+              <a:rPr sz="1300" dirty="0">
+                <a:solidFill>
+                  <a:srgbClr val="DCEFD1"/>
+                </a:solidFill>
+                <a:latin typeface="Consolas"/>
+              </a:rPr>
+              <a:t>"&gt;</a:t>
+            </a:r>
+          </a:p>
+          <a:p>
+            <a:r>
+              <a:rPr sz="1300" dirty="0">
+                <a:solidFill>
+                  <a:srgbClr val="DCEFD1"/>
+                </a:solidFill>
+                <a:latin typeface="Consolas"/>
+              </a:rPr>
+              <a:t>&lt;label for="</a:t>
+            </a:r>
+            <a:r>
+              <a:rPr sz="1300" dirty="0" err="1">
+                <a:solidFill>
+                  <a:srgbClr val="DCEFD1"/>
+                </a:solidFill>
+                <a:latin typeface="Consolas"/>
+              </a:rPr>
+              <a:t>pesan</a:t>
+            </a:r>
+            <a:r>
+              <a:rPr sz="1300" dirty="0">
+                <a:solidFill>
+                  <a:srgbClr val="DCEFD1"/>
+                </a:solidFill>
+                <a:latin typeface="Consolas"/>
+              </a:rPr>
+              <a:t>"&gt;</a:t>
+            </a:r>
+            <a:r>
+              <a:rPr sz="1300" dirty="0" err="1">
+                <a:solidFill>
+                  <a:srgbClr val="DCEFD1"/>
+                </a:solidFill>
+                <a:latin typeface="Consolas"/>
+              </a:rPr>
+              <a:t>Pesan</a:t>
+            </a:r>
+            <a:r>
+              <a:rPr sz="1300" dirty="0">
+                <a:solidFill>
+                  <a:srgbClr val="DCEFD1"/>
+                </a:solidFill>
+                <a:latin typeface="Consolas"/>
+              </a:rPr>
+              <a:t>&lt;/label&gt;</a:t>
+            </a:r>
+          </a:p>
+          <a:p>
+            <a:r>
+              <a:rPr sz="1300" dirty="0">
+                <a:solidFill>
+                  <a:srgbClr val="DCEFD1"/>
+                </a:solidFill>
+                <a:latin typeface="Consolas"/>
+              </a:rPr>
+              <a:t>&lt;</a:t>
+            </a:r>
+            <a:r>
+              <a:rPr sz="1300" dirty="0" err="1">
+                <a:solidFill>
+                  <a:srgbClr val="DCEFD1"/>
+                </a:solidFill>
+                <a:latin typeface="Consolas"/>
+              </a:rPr>
+              <a:t>textarea</a:t>
+            </a:r>
+            <a:r>
+              <a:rPr sz="1300" dirty="0">
+                <a:solidFill>
+                  <a:srgbClr val="DCEFD1"/>
+                </a:solidFill>
+                <a:latin typeface="Consolas"/>
+              </a:rPr>
+              <a:t> id="</a:t>
+            </a:r>
+            <a:r>
+              <a:rPr sz="1300" dirty="0" err="1">
+                <a:solidFill>
+                  <a:srgbClr val="DCEFD1"/>
+                </a:solidFill>
+                <a:latin typeface="Consolas"/>
+              </a:rPr>
+              <a:t>pesan</a:t>
+            </a:r>
+            <a:r>
+              <a:rPr sz="1300" dirty="0">
+                <a:solidFill>
+                  <a:srgbClr val="DCEFD1"/>
+                </a:solidFill>
+                <a:latin typeface="Consolas"/>
+              </a:rPr>
+              <a:t>" name="</a:t>
+            </a:r>
+            <a:r>
+              <a:rPr sz="1300" dirty="0" err="1">
+                <a:solidFill>
+                  <a:srgbClr val="DCEFD1"/>
+                </a:solidFill>
+                <a:latin typeface="Consolas"/>
+              </a:rPr>
+              <a:t>pesan</a:t>
+            </a:r>
+            <a:r>
+              <a:rPr sz="1300" dirty="0">
+                <a:solidFill>
+                  <a:srgbClr val="DCEFD1"/>
+                </a:solidFill>
+                <a:latin typeface="Consolas"/>
+              </a:rPr>
+              <a:t>" placeholder="Tulis </a:t>
+            </a:r>
+            <a:r>
+              <a:rPr sz="1300" dirty="0" err="1">
+                <a:solidFill>
+                  <a:srgbClr val="DCEFD1"/>
+                </a:solidFill>
+                <a:latin typeface="Consolas"/>
+              </a:rPr>
+              <a:t>pesan</a:t>
+            </a:r>
+            <a:r>
+              <a:rPr sz="1300" dirty="0">
+                <a:solidFill>
+                  <a:srgbClr val="DCEFD1"/>
+                </a:solidFill>
+                <a:latin typeface="Consolas"/>
+              </a:rPr>
+              <a:t>..."&gt;&lt;/</a:t>
+            </a:r>
+            <a:r>
+              <a:rPr sz="1300" dirty="0" err="1">
+                <a:solidFill>
+                  <a:srgbClr val="DCEFD1"/>
+                </a:solidFill>
+                <a:latin typeface="Consolas"/>
+              </a:rPr>
+              <a:t>textarea</a:t>
+            </a:r>
+            <a:r>
+              <a:rPr sz="1300" dirty="0">
+                <a:solidFill>
+                  <a:srgbClr val="DCEFD1"/>
+                </a:solidFill>
+                <a:latin typeface="Consolas"/>
+              </a:rPr>
+              <a:t>&gt;</a:t>
+            </a:r>
+          </a:p>
+          <a:p>
+            <a:r>
+              <a:rPr sz="1300" dirty="0">
+                <a:solidFill>
+                  <a:srgbClr val="DCEFD1"/>
+                </a:solidFill>
+                <a:latin typeface="Consolas"/>
+              </a:rPr>
+              <a:t>&lt;button type="submit"&gt;Kirim&lt;/button&gt;</a:t>
             </a:r>
           </a:p>
         </p:txBody>
@@ -5118,7 +5010,7 @@
                 </a:solidFill>
                 <a:latin typeface="Calibri"/>
               </a:rPr>
-              <a:t>10</a:t>
+              <a:t>9</a:t>
             </a:r>
           </a:p>
         </p:txBody>
@@ -5132,6 +5024,835 @@
 </file>
 
 <file path=ppt/slides/slide12.xml><?xml version="1.0" encoding="utf-8"?>
+<p:sld xmlns:a="http://schemas.openxmlformats.org/drawingml/2006/main" xmlns:r="http://schemas.openxmlformats.org/officeDocument/2006/relationships" xmlns:p="http://schemas.openxmlformats.org/presentationml/2006/main">
+  <p:cSld>
+    <p:spTree>
+      <p:nvGrpSpPr>
+        <p:cNvPr id="1" name=""/>
+        <p:cNvGrpSpPr/>
+        <p:nvPr/>
+      </p:nvGrpSpPr>
+      <p:grpSpPr>
+        <a:xfrm>
+          <a:off x="0" y="0"/>
+          <a:ext cx="0" cy="0"/>
+          <a:chOff x="0" y="0"/>
+          <a:chExt cx="0" cy="0"/>
+        </a:xfrm>
+      </p:grpSpPr>
+      <p:sp>
+        <p:nvSpPr>
+          <p:cNvPr id="2" name="Rectangle 1"/>
+          <p:cNvSpPr/>
+          <p:nvPr/>
+        </p:nvSpPr>
+        <p:spPr>
+          <a:xfrm>
+            <a:off x="0" y="0"/>
+            <a:ext cx="12191695" cy="6858000"/>
+          </a:xfrm>
+          <a:prstGeom prst="rect">
+            <a:avLst/>
+          </a:prstGeom>
+          <a:solidFill>
+            <a:srgbClr val="F6F3E7"/>
+          </a:solidFill>
+          <a:ln>
+            <a:noFill/>
+          </a:ln>
+          <a:effectLst/>
+        </p:spPr>
+        <p:style>
+          <a:lnRef idx="1">
+            <a:schemeClr val="accent1"/>
+          </a:lnRef>
+          <a:fillRef idx="3">
+            <a:schemeClr val="accent1"/>
+          </a:fillRef>
+          <a:effectRef idx="2">
+            <a:schemeClr val="accent1"/>
+          </a:effectRef>
+          <a:fontRef idx="minor">
+            <a:schemeClr val="lt1"/>
+          </a:fontRef>
+        </p:style>
+        <p:txBody>
+          <a:bodyPr rtlCol="0" anchor="ctr"/>
+          <a:lstStyle/>
+          <a:p>
+            <a:pPr algn="ctr"/>
+            <a:endParaRPr/>
+          </a:p>
+        </p:txBody>
+      </p:sp>
+      <p:sp>
+        <p:nvSpPr>
+          <p:cNvPr id="3" name="Rectangle 2"/>
+          <p:cNvSpPr/>
+          <p:nvPr/>
+        </p:nvSpPr>
+        <p:spPr>
+          <a:xfrm>
+            <a:off x="0" y="0"/>
+            <a:ext cx="12191695" cy="109728"/>
+          </a:xfrm>
+          <a:prstGeom prst="rect">
+            <a:avLst/>
+          </a:prstGeom>
+          <a:solidFill>
+            <a:srgbClr val="7C9473"/>
+          </a:solidFill>
+          <a:ln>
+            <a:noFill/>
+          </a:ln>
+          <a:effectLst/>
+        </p:spPr>
+        <p:style>
+          <a:lnRef idx="1">
+            <a:schemeClr val="accent1"/>
+          </a:lnRef>
+          <a:fillRef idx="3">
+            <a:schemeClr val="accent1"/>
+          </a:fillRef>
+          <a:effectRef idx="2">
+            <a:schemeClr val="accent1"/>
+          </a:effectRef>
+          <a:fontRef idx="minor">
+            <a:schemeClr val="lt1"/>
+          </a:fontRef>
+        </p:style>
+        <p:txBody>
+          <a:bodyPr rtlCol="0" anchor="ctr"/>
+          <a:lstStyle/>
+          <a:p>
+            <a:pPr algn="ctr"/>
+            <a:endParaRPr/>
+          </a:p>
+        </p:txBody>
+      </p:sp>
+      <p:sp>
+        <p:nvSpPr>
+          <p:cNvPr id="4" name="TextBox 3"/>
+          <p:cNvSpPr txBox="1"/>
+          <p:nvPr/>
+        </p:nvSpPr>
+        <p:spPr>
+          <a:xfrm>
+            <a:off x="640080" y="256032"/>
+            <a:ext cx="10911535" cy="320040"/>
+          </a:xfrm>
+          <a:prstGeom prst="rect">
+            <a:avLst/>
+          </a:prstGeom>
+          <a:noFill/>
+        </p:spPr>
+        <p:txBody>
+          <a:bodyPr wrap="none">
+            <a:spAutoFit/>
+          </a:bodyPr>
+          <a:lstStyle/>
+          <a:p>
+            <a:r>
+              <a:rPr sz="1300" b="1">
+                <a:solidFill>
+                  <a:srgbClr val="7C9473"/>
+                </a:solidFill>
+                <a:latin typeface="Calibri"/>
+              </a:rPr>
+              <a:t>TEORI — PERTEMUAN 1 — FONDASI WEB &amp; HTML</a:t>
+            </a:r>
+          </a:p>
+        </p:txBody>
+      </p:sp>
+      <p:sp>
+        <p:nvSpPr>
+          <p:cNvPr id="5" name="TextBox 4"/>
+          <p:cNvSpPr txBox="1"/>
+          <p:nvPr/>
+        </p:nvSpPr>
+        <p:spPr>
+          <a:xfrm>
+            <a:off x="640080" y="566928"/>
+            <a:ext cx="10911535" cy="914400"/>
+          </a:xfrm>
+          <a:prstGeom prst="rect">
+            <a:avLst/>
+          </a:prstGeom>
+          <a:noFill/>
+        </p:spPr>
+        <p:txBody>
+          <a:bodyPr wrap="square">
+            <a:spAutoFit/>
+          </a:bodyPr>
+          <a:lstStyle/>
+          <a:p>
+            <a:r>
+              <a:rPr sz="2700" b="1">
+                <a:solidFill>
+                  <a:srgbClr val="33422B"/>
+                </a:solidFill>
+                <a:latin typeface="Poppins"/>
+              </a:rPr>
+              <a:t>Tools yang Dibutuhkan Hari Ini</a:t>
+            </a:r>
+          </a:p>
+        </p:txBody>
+      </p:sp>
+      <p:sp>
+        <p:nvSpPr>
+          <p:cNvPr id="6" name="Rectangle 5"/>
+          <p:cNvSpPr/>
+          <p:nvPr/>
+        </p:nvSpPr>
+        <p:spPr>
+          <a:xfrm>
+            <a:off x="640080" y="1188720"/>
+            <a:ext cx="1005840" cy="38100"/>
+          </a:xfrm>
+          <a:prstGeom prst="rect">
+            <a:avLst/>
+          </a:prstGeom>
+          <a:solidFill>
+            <a:srgbClr val="C9A66B"/>
+          </a:solidFill>
+          <a:ln>
+            <a:noFill/>
+          </a:ln>
+          <a:effectLst/>
+        </p:spPr>
+        <p:style>
+          <a:lnRef idx="1">
+            <a:schemeClr val="accent1"/>
+          </a:lnRef>
+          <a:fillRef idx="3">
+            <a:schemeClr val="accent1"/>
+          </a:fillRef>
+          <a:effectRef idx="2">
+            <a:schemeClr val="accent1"/>
+          </a:effectRef>
+          <a:fontRef idx="minor">
+            <a:schemeClr val="lt1"/>
+          </a:fontRef>
+        </p:style>
+        <p:txBody>
+          <a:bodyPr rtlCol="0" anchor="ctr"/>
+          <a:lstStyle/>
+          <a:p>
+            <a:pPr algn="ctr"/>
+            <a:endParaRPr/>
+          </a:p>
+        </p:txBody>
+      </p:sp>
+      <p:sp>
+        <p:nvSpPr>
+          <p:cNvPr id="7" name="TextBox 6"/>
+          <p:cNvSpPr txBox="1"/>
+          <p:nvPr/>
+        </p:nvSpPr>
+        <p:spPr>
+          <a:xfrm>
+            <a:off x="640080" y="1417320"/>
+            <a:ext cx="10911535" cy="914400"/>
+          </a:xfrm>
+          <a:prstGeom prst="rect">
+            <a:avLst/>
+          </a:prstGeom>
+          <a:noFill/>
+        </p:spPr>
+        <p:txBody>
+          <a:bodyPr wrap="square">
+            <a:spAutoFit/>
+          </a:bodyPr>
+          <a:lstStyle/>
+          <a:p>
+            <a:r>
+              <a:rPr sz="1700" i="0">
+                <a:solidFill>
+                  <a:srgbClr val="33422B"/>
+                </a:solidFill>
+                <a:latin typeface="Calibri"/>
+              </a:rPr>
+              <a:t>Sebelum mulai ngoding, siapkan tiga hal ini dulu di laptop kamu.</a:t>
+            </a:r>
+          </a:p>
+        </p:txBody>
+      </p:sp>
+      <p:sp>
+        <p:nvSpPr>
+          <p:cNvPr id="8" name="TextBox 7"/>
+          <p:cNvSpPr txBox="1"/>
+          <p:nvPr/>
+        </p:nvSpPr>
+        <p:spPr>
+          <a:xfrm>
+            <a:off x="640081" y="2194560"/>
+            <a:ext cx="10439400" cy="1036181"/>
+          </a:xfrm>
+          <a:prstGeom prst="rect">
+            <a:avLst/>
+          </a:prstGeom>
+          <a:noFill/>
+        </p:spPr>
+        <p:txBody>
+          <a:bodyPr wrap="square">
+            <a:spAutoFit/>
+          </a:bodyPr>
+          <a:lstStyle/>
+          <a:p>
+            <a:pPr>
+              <a:spcAft>
+                <a:spcPts val="800"/>
+              </a:spcAft>
+            </a:pPr>
+            <a:r>
+              <a:rPr sz="1600" b="1" dirty="0">
+                <a:solidFill>
+                  <a:srgbClr val="7C9473"/>
+                </a:solidFill>
+              </a:rPr>
+              <a:t>●  </a:t>
+            </a:r>
+            <a:r>
+              <a:rPr sz="1600" dirty="0">
+                <a:solidFill>
+                  <a:srgbClr val="33422B"/>
+                </a:solidFill>
+                <a:latin typeface="Calibri"/>
+              </a:rPr>
+              <a:t>VS Code — </a:t>
+            </a:r>
+            <a:r>
+              <a:rPr sz="1600" dirty="0" err="1">
+                <a:solidFill>
+                  <a:srgbClr val="33422B"/>
+                </a:solidFill>
+                <a:latin typeface="Calibri"/>
+              </a:rPr>
+              <a:t>unduh</a:t>
+            </a:r>
+            <a:r>
+              <a:rPr sz="1600" dirty="0">
+                <a:solidFill>
+                  <a:srgbClr val="33422B"/>
+                </a:solidFill>
+                <a:latin typeface="Calibri"/>
+              </a:rPr>
+              <a:t> di code.visualstudio.com/Download — editor </a:t>
+            </a:r>
+            <a:r>
+              <a:rPr sz="1600" dirty="0" err="1">
+                <a:solidFill>
+                  <a:srgbClr val="33422B"/>
+                </a:solidFill>
+                <a:latin typeface="Calibri"/>
+              </a:rPr>
+              <a:t>tempat</a:t>
+            </a:r>
+            <a:r>
+              <a:rPr sz="1600" dirty="0">
+                <a:solidFill>
+                  <a:srgbClr val="33422B"/>
+                </a:solidFill>
+                <a:latin typeface="Calibri"/>
+              </a:rPr>
+              <a:t> </a:t>
+            </a:r>
+            <a:r>
+              <a:rPr sz="1600" dirty="0" err="1">
+                <a:solidFill>
+                  <a:srgbClr val="33422B"/>
+                </a:solidFill>
+                <a:latin typeface="Calibri"/>
+              </a:rPr>
+              <a:t>kita</a:t>
+            </a:r>
+            <a:r>
+              <a:rPr sz="1600" dirty="0">
+                <a:solidFill>
+                  <a:srgbClr val="33422B"/>
+                </a:solidFill>
+                <a:latin typeface="Calibri"/>
+              </a:rPr>
+              <a:t> </a:t>
+            </a:r>
+            <a:r>
+              <a:rPr sz="1600" dirty="0" err="1">
+                <a:solidFill>
+                  <a:srgbClr val="33422B"/>
+                </a:solidFill>
+                <a:latin typeface="Calibri"/>
+              </a:rPr>
+              <a:t>menulis</a:t>
+            </a:r>
+            <a:r>
+              <a:rPr sz="1600" dirty="0">
+                <a:solidFill>
+                  <a:srgbClr val="33422B"/>
+                </a:solidFill>
+                <a:latin typeface="Calibri"/>
+              </a:rPr>
+              <a:t> </a:t>
+            </a:r>
+            <a:r>
+              <a:rPr sz="1600" dirty="0" err="1">
+                <a:solidFill>
+                  <a:srgbClr val="33422B"/>
+                </a:solidFill>
+                <a:latin typeface="Calibri"/>
+              </a:rPr>
+              <a:t>semua</a:t>
+            </a:r>
+            <a:r>
+              <a:rPr sz="1600" dirty="0">
+                <a:solidFill>
+                  <a:srgbClr val="33422B"/>
+                </a:solidFill>
+                <a:latin typeface="Calibri"/>
+              </a:rPr>
+              <a:t> </a:t>
+            </a:r>
+            <a:r>
+              <a:rPr sz="1600" dirty="0" err="1">
+                <a:solidFill>
+                  <a:srgbClr val="33422B"/>
+                </a:solidFill>
+                <a:latin typeface="Calibri"/>
+              </a:rPr>
+              <a:t>kode</a:t>
+            </a:r>
+            <a:r>
+              <a:rPr sz="1600" dirty="0">
+                <a:solidFill>
+                  <a:srgbClr val="33422B"/>
+                </a:solidFill>
+                <a:latin typeface="Calibri"/>
+              </a:rPr>
+              <a:t> HTML</a:t>
+            </a:r>
+            <a:r>
+              <a:rPr lang="en-US" sz="1600" dirty="0">
+                <a:solidFill>
+                  <a:srgbClr val="33422B"/>
+                </a:solidFill>
+                <a:latin typeface="Calibri"/>
+              </a:rPr>
+              <a:t>.</a:t>
+            </a:r>
+            <a:endParaRPr sz="1600" dirty="0">
+              <a:solidFill>
+                <a:srgbClr val="33422B"/>
+              </a:solidFill>
+              <a:latin typeface="Calibri"/>
+            </a:endParaRPr>
+          </a:p>
+          <a:p>
+            <a:pPr>
+              <a:spcAft>
+                <a:spcPts val="800"/>
+              </a:spcAft>
+            </a:pPr>
+            <a:r>
+              <a:rPr sz="1600" b="1" dirty="0">
+                <a:solidFill>
+                  <a:srgbClr val="7C9473"/>
+                </a:solidFill>
+              </a:rPr>
+              <a:t>●  </a:t>
+            </a:r>
+            <a:r>
+              <a:rPr sz="1600" dirty="0" err="1">
+                <a:solidFill>
+                  <a:srgbClr val="33422B"/>
+                </a:solidFill>
+                <a:latin typeface="Calibri"/>
+              </a:rPr>
+              <a:t>Ekstensi</a:t>
+            </a:r>
+            <a:r>
+              <a:rPr sz="1600" dirty="0">
+                <a:solidFill>
+                  <a:srgbClr val="33422B"/>
+                </a:solidFill>
+                <a:latin typeface="Calibri"/>
+              </a:rPr>
+              <a:t> Live Server — </a:t>
+            </a:r>
+            <a:r>
+              <a:rPr sz="1600" dirty="0" err="1">
+                <a:solidFill>
+                  <a:srgbClr val="33422B"/>
+                </a:solidFill>
+                <a:latin typeface="Calibri"/>
+              </a:rPr>
+              <a:t>cari</a:t>
+            </a:r>
+            <a:r>
+              <a:rPr sz="1600" dirty="0">
+                <a:solidFill>
+                  <a:srgbClr val="33422B"/>
+                </a:solidFill>
+                <a:latin typeface="Calibri"/>
+              </a:rPr>
+              <a:t> </a:t>
+            </a:r>
+            <a:r>
+              <a:rPr sz="1600" dirty="0" err="1">
+                <a:solidFill>
+                  <a:srgbClr val="33422B"/>
+                </a:solidFill>
+                <a:latin typeface="Calibri"/>
+              </a:rPr>
+              <a:t>lewat</a:t>
+            </a:r>
+            <a:r>
+              <a:rPr sz="1600" dirty="0">
+                <a:solidFill>
+                  <a:srgbClr val="33422B"/>
+                </a:solidFill>
+                <a:latin typeface="Calibri"/>
+              </a:rPr>
+              <a:t> marketplace.visualstudio.com </a:t>
+            </a:r>
+            <a:r>
+              <a:rPr sz="1600" dirty="0" err="1">
+                <a:solidFill>
+                  <a:srgbClr val="33422B"/>
+                </a:solidFill>
+                <a:latin typeface="Calibri"/>
+              </a:rPr>
+              <a:t>atau</a:t>
+            </a:r>
+            <a:r>
+              <a:rPr sz="1600" dirty="0">
+                <a:solidFill>
+                  <a:srgbClr val="33422B"/>
+                </a:solidFill>
+                <a:latin typeface="Calibri"/>
+              </a:rPr>
+              <a:t> </a:t>
+            </a:r>
+            <a:r>
+              <a:rPr sz="1600" dirty="0" err="1">
+                <a:solidFill>
+                  <a:srgbClr val="33422B"/>
+                </a:solidFill>
+                <a:latin typeface="Calibri"/>
+              </a:rPr>
+              <a:t>langsung</a:t>
+            </a:r>
+            <a:r>
+              <a:rPr sz="1600" dirty="0">
+                <a:solidFill>
+                  <a:srgbClr val="33422B"/>
+                </a:solidFill>
+                <a:latin typeface="Calibri"/>
+              </a:rPr>
+              <a:t> </a:t>
+            </a:r>
+            <a:r>
+              <a:rPr sz="1600" dirty="0" err="1">
+                <a:solidFill>
+                  <a:srgbClr val="33422B"/>
+                </a:solidFill>
+                <a:latin typeface="Calibri"/>
+              </a:rPr>
+              <a:t>dari</a:t>
+            </a:r>
+            <a:r>
+              <a:rPr sz="1600" dirty="0">
+                <a:solidFill>
+                  <a:srgbClr val="33422B"/>
+                </a:solidFill>
+                <a:latin typeface="Calibri"/>
+              </a:rPr>
+              <a:t> tab Extensions</a:t>
+            </a:r>
+            <a:r>
+              <a:rPr lang="en-US" sz="1600" dirty="0">
+                <a:solidFill>
+                  <a:srgbClr val="33422B"/>
+                </a:solidFill>
+                <a:latin typeface="Calibri"/>
+              </a:rPr>
+              <a:t>.</a:t>
+            </a:r>
+            <a:endParaRPr sz="1600" dirty="0">
+              <a:solidFill>
+                <a:srgbClr val="33422B"/>
+              </a:solidFill>
+              <a:latin typeface="Calibri"/>
+            </a:endParaRPr>
+          </a:p>
+          <a:p>
+            <a:pPr>
+              <a:spcAft>
+                <a:spcPts val="800"/>
+              </a:spcAft>
+            </a:pPr>
+            <a:r>
+              <a:rPr sz="1600" b="1" dirty="0">
+                <a:solidFill>
+                  <a:srgbClr val="7C9473"/>
+                </a:solidFill>
+              </a:rPr>
+              <a:t>●  </a:t>
+            </a:r>
+            <a:r>
+              <a:rPr sz="1600" dirty="0">
+                <a:solidFill>
+                  <a:srgbClr val="33422B"/>
+                </a:solidFill>
+                <a:latin typeface="Calibri"/>
+              </a:rPr>
+              <a:t>Browser modern — Chrome (google.com/chrome) </a:t>
+            </a:r>
+            <a:r>
+              <a:rPr sz="1600" dirty="0" err="1">
+                <a:solidFill>
+                  <a:srgbClr val="33422B"/>
+                </a:solidFill>
+                <a:latin typeface="Calibri"/>
+              </a:rPr>
+              <a:t>atau</a:t>
+            </a:r>
+            <a:r>
+              <a:rPr sz="1600" dirty="0">
+                <a:solidFill>
+                  <a:srgbClr val="33422B"/>
+                </a:solidFill>
+                <a:latin typeface="Calibri"/>
+              </a:rPr>
+              <a:t> Edge (</a:t>
+            </a:r>
+            <a:r>
+              <a:rPr sz="1600" dirty="0" err="1">
+                <a:solidFill>
+                  <a:srgbClr val="33422B"/>
+                </a:solidFill>
+                <a:latin typeface="Calibri"/>
+              </a:rPr>
+              <a:t>sudah</a:t>
+            </a:r>
+            <a:r>
+              <a:rPr sz="1600" dirty="0">
+                <a:solidFill>
+                  <a:srgbClr val="33422B"/>
+                </a:solidFill>
+                <a:latin typeface="Calibri"/>
+              </a:rPr>
+              <a:t> </a:t>
+            </a:r>
+            <a:r>
+              <a:rPr sz="1600" dirty="0" err="1">
+                <a:solidFill>
+                  <a:srgbClr val="33422B"/>
+                </a:solidFill>
+                <a:latin typeface="Calibri"/>
+              </a:rPr>
+              <a:t>terpasang</a:t>
+            </a:r>
+            <a:r>
+              <a:rPr sz="1600" dirty="0">
+                <a:solidFill>
+                  <a:srgbClr val="33422B"/>
+                </a:solidFill>
+                <a:latin typeface="Calibri"/>
+              </a:rPr>
+              <a:t> </a:t>
+            </a:r>
+            <a:r>
+              <a:rPr sz="1600" dirty="0" err="1">
+                <a:solidFill>
+                  <a:srgbClr val="33422B"/>
+                </a:solidFill>
+                <a:latin typeface="Calibri"/>
+              </a:rPr>
+              <a:t>bawaan</a:t>
+            </a:r>
+            <a:r>
+              <a:rPr sz="1600" dirty="0">
+                <a:solidFill>
+                  <a:srgbClr val="33422B"/>
+                </a:solidFill>
+                <a:latin typeface="Calibri"/>
+              </a:rPr>
+              <a:t> di Windows)</a:t>
+            </a:r>
+            <a:r>
+              <a:rPr lang="en-US" sz="1600" dirty="0">
+                <a:solidFill>
+                  <a:srgbClr val="33422B"/>
+                </a:solidFill>
+                <a:latin typeface="Calibri"/>
+              </a:rPr>
+              <a:t>.</a:t>
+            </a:r>
+            <a:endParaRPr sz="1600" dirty="0">
+              <a:solidFill>
+                <a:srgbClr val="33422B"/>
+              </a:solidFill>
+              <a:latin typeface="Calibri"/>
+            </a:endParaRPr>
+          </a:p>
+        </p:txBody>
+      </p:sp>
+      <p:sp>
+        <p:nvSpPr>
+          <p:cNvPr id="9" name="TextBox 8"/>
+          <p:cNvSpPr txBox="1"/>
+          <p:nvPr/>
+        </p:nvSpPr>
+        <p:spPr>
+          <a:xfrm>
+            <a:off x="640080" y="5989320"/>
+            <a:ext cx="10911535" cy="914400"/>
+          </a:xfrm>
+          <a:prstGeom prst="rect">
+            <a:avLst/>
+          </a:prstGeom>
+          <a:noFill/>
+        </p:spPr>
+        <p:txBody>
+          <a:bodyPr wrap="square">
+            <a:spAutoFit/>
+          </a:bodyPr>
+          <a:lstStyle/>
+          <a:p>
+            <a:r>
+              <a:rPr sz="1300" i="1">
+                <a:solidFill>
+                  <a:srgbClr val="5A6652"/>
+                </a:solidFill>
+                <a:latin typeface="Calibri"/>
+              </a:rPr>
+              <a:t>🖼  Tambahkan gambar: screenshot VS Code dengan panel Extensions terbuka, ekstensi Live Server ter-highlight.</a:t>
+            </a:r>
+          </a:p>
+        </p:txBody>
+      </p:sp>
+      <p:sp>
+        <p:nvSpPr>
+          <p:cNvPr id="10" name="Rectangle 9"/>
+          <p:cNvSpPr/>
+          <p:nvPr/>
+        </p:nvSpPr>
+        <p:spPr>
+          <a:xfrm>
+            <a:off x="640080" y="6355080"/>
+            <a:ext cx="10911535" cy="12700"/>
+          </a:xfrm>
+          <a:prstGeom prst="rect">
+            <a:avLst/>
+          </a:prstGeom>
+          <a:solidFill>
+            <a:srgbClr val="C9A66B"/>
+          </a:solidFill>
+          <a:ln>
+            <a:noFill/>
+          </a:ln>
+          <a:effectLst/>
+        </p:spPr>
+        <p:style>
+          <a:lnRef idx="1">
+            <a:schemeClr val="accent1"/>
+          </a:lnRef>
+          <a:fillRef idx="3">
+            <a:schemeClr val="accent1"/>
+          </a:fillRef>
+          <a:effectRef idx="2">
+            <a:schemeClr val="accent1"/>
+          </a:effectRef>
+          <a:fontRef idx="minor">
+            <a:schemeClr val="lt1"/>
+          </a:fontRef>
+        </p:style>
+        <p:txBody>
+          <a:bodyPr rtlCol="0" anchor="ctr"/>
+          <a:lstStyle/>
+          <a:p>
+            <a:pPr algn="ctr"/>
+            <a:endParaRPr/>
+          </a:p>
+        </p:txBody>
+      </p:sp>
+      <p:sp>
+        <p:nvSpPr>
+          <p:cNvPr id="11" name="TextBox 10"/>
+          <p:cNvSpPr txBox="1"/>
+          <p:nvPr/>
+        </p:nvSpPr>
+        <p:spPr>
+          <a:xfrm>
+            <a:off x="640080" y="6437376"/>
+            <a:ext cx="10362895" cy="274320"/>
+          </a:xfrm>
+          <a:prstGeom prst="rect">
+            <a:avLst/>
+          </a:prstGeom>
+          <a:noFill/>
+        </p:spPr>
+        <p:txBody>
+          <a:bodyPr wrap="none">
+            <a:spAutoFit/>
+          </a:bodyPr>
+          <a:lstStyle/>
+          <a:p>
+            <a:r>
+              <a:rPr sz="1100">
+                <a:solidFill>
+                  <a:srgbClr val="5A6652"/>
+                </a:solidFill>
+                <a:latin typeface="Calibri"/>
+              </a:rPr>
+              <a:t>Website UNSIKA — Pertemuan 1 — Fondasi Web &amp; HTML</a:t>
+            </a:r>
+          </a:p>
+        </p:txBody>
+      </p:sp>
+      <p:sp>
+        <p:nvSpPr>
+          <p:cNvPr id="12" name="TextBox 11"/>
+          <p:cNvSpPr txBox="1"/>
+          <p:nvPr/>
+        </p:nvSpPr>
+        <p:spPr>
+          <a:xfrm>
+            <a:off x="11185855" y="6437376"/>
+            <a:ext cx="457200" cy="274320"/>
+          </a:xfrm>
+          <a:prstGeom prst="rect">
+            <a:avLst/>
+          </a:prstGeom>
+          <a:noFill/>
+        </p:spPr>
+        <p:txBody>
+          <a:bodyPr wrap="none">
+            <a:spAutoFit/>
+          </a:bodyPr>
+          <a:lstStyle/>
+          <a:p>
+            <a:pPr algn="r"/>
+            <a:r>
+              <a:rPr sz="1100" b="1">
+                <a:solidFill>
+                  <a:srgbClr val="C9A66B"/>
+                </a:solidFill>
+                <a:latin typeface="Calibri"/>
+              </a:rPr>
+              <a:t>10</a:t>
+            </a:r>
+          </a:p>
+        </p:txBody>
+      </p:sp>
+    </p:spTree>
+  </p:cSld>
+  <p:clrMapOvr>
+    <a:masterClrMapping/>
+  </p:clrMapOvr>
+</p:sld>
+</file>
+
+<file path=ppt/slides/slide13.xml><?xml version="1.0" encoding="utf-8"?>
 <p:sld xmlns:a="http://schemas.openxmlformats.org/drawingml/2006/main" xmlns:r="http://schemas.openxmlformats.org/officeDocument/2006/relationships" xmlns:p="http://schemas.openxmlformats.org/presentationml/2006/main">
   <p:cSld>
     <p:spTree>
@@ -5958,7 +6679,7 @@
 </p:sld>
 </file>
 
-<file path=ppt/slides/slide13.xml><?xml version="1.0" encoding="utf-8"?>
+<file path=ppt/slides/slide14.xml><?xml version="1.0" encoding="utf-8"?>
 <p:sld xmlns:a="http://schemas.openxmlformats.org/drawingml/2006/main" xmlns:r="http://schemas.openxmlformats.org/officeDocument/2006/relationships" xmlns:p="http://schemas.openxmlformats.org/presentationml/2006/main">
   <p:cSld>
     <p:bg>
@@ -9417,6 +10138,437 @@
   <p:cSld>
     <p:spTree>
       <p:nvGrpSpPr>
+        <p:cNvPr id="1" name="">
+          <a:extLst>
+            <a:ext uri="{FF2B5EF4-FFF2-40B4-BE49-F238E27FC236}">
+              <a16:creationId xmlns:a16="http://schemas.microsoft.com/office/drawing/2014/main" id="{19142C9D-97AF-B8AC-C190-658CEA106162}"/>
+            </a:ext>
+          </a:extLst>
+        </p:cNvPr>
+        <p:cNvGrpSpPr/>
+        <p:nvPr/>
+      </p:nvGrpSpPr>
+      <p:grpSpPr>
+        <a:xfrm>
+          <a:off x="0" y="0"/>
+          <a:ext cx="0" cy="0"/>
+          <a:chOff x="0" y="0"/>
+          <a:chExt cx="0" cy="0"/>
+        </a:xfrm>
+      </p:grpSpPr>
+      <p:sp>
+        <p:nvSpPr>
+          <p:cNvPr id="2" name="Rectangle 1">
+            <a:extLst>
+              <a:ext uri="{FF2B5EF4-FFF2-40B4-BE49-F238E27FC236}">
+                <a16:creationId xmlns:a16="http://schemas.microsoft.com/office/drawing/2014/main" id="{AE81B93F-6675-6D2E-A4CB-1B0775068D46}"/>
+              </a:ext>
+            </a:extLst>
+          </p:cNvPr>
+          <p:cNvSpPr/>
+          <p:nvPr/>
+        </p:nvSpPr>
+        <p:spPr>
+          <a:xfrm>
+            <a:off x="0" y="0"/>
+            <a:ext cx="12191695" cy="6858000"/>
+          </a:xfrm>
+          <a:prstGeom prst="rect">
+            <a:avLst/>
+          </a:prstGeom>
+          <a:solidFill>
+            <a:srgbClr val="F6F3E7"/>
+          </a:solidFill>
+          <a:ln>
+            <a:noFill/>
+          </a:ln>
+          <a:effectLst/>
+        </p:spPr>
+        <p:style>
+          <a:lnRef idx="1">
+            <a:schemeClr val="accent1"/>
+          </a:lnRef>
+          <a:fillRef idx="3">
+            <a:schemeClr val="accent1"/>
+          </a:fillRef>
+          <a:effectRef idx="2">
+            <a:schemeClr val="accent1"/>
+          </a:effectRef>
+          <a:fontRef idx="minor">
+            <a:schemeClr val="lt1"/>
+          </a:fontRef>
+        </p:style>
+        <p:txBody>
+          <a:bodyPr rtlCol="0" anchor="ctr"/>
+          <a:lstStyle/>
+          <a:p>
+            <a:pPr algn="ctr"/>
+            <a:endParaRPr/>
+          </a:p>
+        </p:txBody>
+      </p:sp>
+      <p:sp>
+        <p:nvSpPr>
+          <p:cNvPr id="3" name="Rectangle 2">
+            <a:extLst>
+              <a:ext uri="{FF2B5EF4-FFF2-40B4-BE49-F238E27FC236}">
+                <a16:creationId xmlns:a16="http://schemas.microsoft.com/office/drawing/2014/main" id="{E4B14861-C309-4200-78D3-FD6A9B79B5C9}"/>
+              </a:ext>
+            </a:extLst>
+          </p:cNvPr>
+          <p:cNvSpPr/>
+          <p:nvPr/>
+        </p:nvSpPr>
+        <p:spPr>
+          <a:xfrm>
+            <a:off x="0" y="0"/>
+            <a:ext cx="12191695" cy="109728"/>
+          </a:xfrm>
+          <a:prstGeom prst="rect">
+            <a:avLst/>
+          </a:prstGeom>
+          <a:solidFill>
+            <a:srgbClr val="7C9473"/>
+          </a:solidFill>
+          <a:ln>
+            <a:noFill/>
+          </a:ln>
+          <a:effectLst/>
+        </p:spPr>
+        <p:style>
+          <a:lnRef idx="1">
+            <a:schemeClr val="accent1"/>
+          </a:lnRef>
+          <a:fillRef idx="3">
+            <a:schemeClr val="accent1"/>
+          </a:fillRef>
+          <a:effectRef idx="2">
+            <a:schemeClr val="accent1"/>
+          </a:effectRef>
+          <a:fontRef idx="minor">
+            <a:schemeClr val="lt1"/>
+          </a:fontRef>
+        </p:style>
+        <p:txBody>
+          <a:bodyPr rtlCol="0" anchor="ctr"/>
+          <a:lstStyle/>
+          <a:p>
+            <a:pPr algn="ctr"/>
+            <a:endParaRPr/>
+          </a:p>
+        </p:txBody>
+      </p:sp>
+      <p:sp>
+        <p:nvSpPr>
+          <p:cNvPr id="4" name="TextBox 3">
+            <a:extLst>
+              <a:ext uri="{FF2B5EF4-FFF2-40B4-BE49-F238E27FC236}">
+                <a16:creationId xmlns:a16="http://schemas.microsoft.com/office/drawing/2014/main" id="{4791498A-C85D-2A41-CAA4-C2F0B9C05912}"/>
+              </a:ext>
+            </a:extLst>
+          </p:cNvPr>
+          <p:cNvSpPr txBox="1"/>
+          <p:nvPr/>
+        </p:nvSpPr>
+        <p:spPr>
+          <a:xfrm>
+            <a:off x="640080" y="256032"/>
+            <a:ext cx="10911535" cy="320040"/>
+          </a:xfrm>
+          <a:prstGeom prst="rect">
+            <a:avLst/>
+          </a:prstGeom>
+          <a:noFill/>
+        </p:spPr>
+        <p:txBody>
+          <a:bodyPr wrap="none">
+            <a:spAutoFit/>
+          </a:bodyPr>
+          <a:lstStyle/>
+          <a:p>
+            <a:r>
+              <a:rPr sz="1300" b="1">
+                <a:solidFill>
+                  <a:srgbClr val="7C9473"/>
+                </a:solidFill>
+                <a:latin typeface="Calibri"/>
+              </a:rPr>
+              <a:t>TEORI — PERTEMUAN 1 — FONDASI WEB &amp; HTML</a:t>
+            </a:r>
+          </a:p>
+        </p:txBody>
+      </p:sp>
+      <p:sp>
+        <p:nvSpPr>
+          <p:cNvPr id="5" name="TextBox 4">
+            <a:extLst>
+              <a:ext uri="{FF2B5EF4-FFF2-40B4-BE49-F238E27FC236}">
+                <a16:creationId xmlns:a16="http://schemas.microsoft.com/office/drawing/2014/main" id="{17B9F251-1C18-3CA8-2FBA-3694C81E8C35}"/>
+              </a:ext>
+            </a:extLst>
+          </p:cNvPr>
+          <p:cNvSpPr txBox="1"/>
+          <p:nvPr/>
+        </p:nvSpPr>
+        <p:spPr>
+          <a:xfrm>
+            <a:off x="640080" y="566928"/>
+            <a:ext cx="10911535" cy="914400"/>
+          </a:xfrm>
+          <a:prstGeom prst="rect">
+            <a:avLst/>
+          </a:prstGeom>
+          <a:noFill/>
+        </p:spPr>
+        <p:txBody>
+          <a:bodyPr wrap="square">
+            <a:spAutoFit/>
+          </a:bodyPr>
+          <a:lstStyle/>
+          <a:p>
+            <a:r>
+              <a:rPr sz="2700" b="1">
+                <a:solidFill>
+                  <a:srgbClr val="33422B"/>
+                </a:solidFill>
+                <a:latin typeface="Poppins"/>
+              </a:rPr>
+              <a:t>Peran HTML, CSS, dan JavaScript</a:t>
+            </a:r>
+          </a:p>
+        </p:txBody>
+      </p:sp>
+      <p:sp>
+        <p:nvSpPr>
+          <p:cNvPr id="6" name="Rectangle 5">
+            <a:extLst>
+              <a:ext uri="{FF2B5EF4-FFF2-40B4-BE49-F238E27FC236}">
+                <a16:creationId xmlns:a16="http://schemas.microsoft.com/office/drawing/2014/main" id="{CFD0BC61-6FE0-7867-8D5B-567B2426662F}"/>
+              </a:ext>
+            </a:extLst>
+          </p:cNvPr>
+          <p:cNvSpPr/>
+          <p:nvPr/>
+        </p:nvSpPr>
+        <p:spPr>
+          <a:xfrm>
+            <a:off x="640080" y="1188720"/>
+            <a:ext cx="1005840" cy="38100"/>
+          </a:xfrm>
+          <a:prstGeom prst="rect">
+            <a:avLst/>
+          </a:prstGeom>
+          <a:solidFill>
+            <a:srgbClr val="C9A66B"/>
+          </a:solidFill>
+          <a:ln>
+            <a:noFill/>
+          </a:ln>
+          <a:effectLst/>
+        </p:spPr>
+        <p:style>
+          <a:lnRef idx="1">
+            <a:schemeClr val="accent1"/>
+          </a:lnRef>
+          <a:fillRef idx="3">
+            <a:schemeClr val="accent1"/>
+          </a:fillRef>
+          <a:effectRef idx="2">
+            <a:schemeClr val="accent1"/>
+          </a:effectRef>
+          <a:fontRef idx="minor">
+            <a:schemeClr val="lt1"/>
+          </a:fontRef>
+        </p:style>
+        <p:txBody>
+          <a:bodyPr rtlCol="0" anchor="ctr"/>
+          <a:lstStyle/>
+          <a:p>
+            <a:pPr algn="ctr"/>
+            <a:endParaRPr/>
+          </a:p>
+        </p:txBody>
+      </p:sp>
+      <p:sp>
+        <p:nvSpPr>
+          <p:cNvPr id="9" name="Rectangle 8">
+            <a:extLst>
+              <a:ext uri="{FF2B5EF4-FFF2-40B4-BE49-F238E27FC236}">
+                <a16:creationId xmlns:a16="http://schemas.microsoft.com/office/drawing/2014/main" id="{4FA01E6D-5876-00DD-C899-78DCF84C64F4}"/>
+              </a:ext>
+            </a:extLst>
+          </p:cNvPr>
+          <p:cNvSpPr/>
+          <p:nvPr/>
+        </p:nvSpPr>
+        <p:spPr>
+          <a:xfrm>
+            <a:off x="640080" y="6355080"/>
+            <a:ext cx="10911535" cy="12700"/>
+          </a:xfrm>
+          <a:prstGeom prst="rect">
+            <a:avLst/>
+          </a:prstGeom>
+          <a:solidFill>
+            <a:srgbClr val="C9A66B"/>
+          </a:solidFill>
+          <a:ln>
+            <a:noFill/>
+          </a:ln>
+          <a:effectLst/>
+        </p:spPr>
+        <p:style>
+          <a:lnRef idx="1">
+            <a:schemeClr val="accent1"/>
+          </a:lnRef>
+          <a:fillRef idx="3">
+            <a:schemeClr val="accent1"/>
+          </a:fillRef>
+          <a:effectRef idx="2">
+            <a:schemeClr val="accent1"/>
+          </a:effectRef>
+          <a:fontRef idx="minor">
+            <a:schemeClr val="lt1"/>
+          </a:fontRef>
+        </p:style>
+        <p:txBody>
+          <a:bodyPr rtlCol="0" anchor="ctr"/>
+          <a:lstStyle/>
+          <a:p>
+            <a:pPr algn="ctr"/>
+            <a:endParaRPr/>
+          </a:p>
+        </p:txBody>
+      </p:sp>
+      <p:sp>
+        <p:nvSpPr>
+          <p:cNvPr id="10" name="TextBox 9">
+            <a:extLst>
+              <a:ext uri="{FF2B5EF4-FFF2-40B4-BE49-F238E27FC236}">
+                <a16:creationId xmlns:a16="http://schemas.microsoft.com/office/drawing/2014/main" id="{68A4CA51-DE8E-F3E4-2510-551878AA494E}"/>
+              </a:ext>
+            </a:extLst>
+          </p:cNvPr>
+          <p:cNvSpPr txBox="1"/>
+          <p:nvPr/>
+        </p:nvSpPr>
+        <p:spPr>
+          <a:xfrm>
+            <a:off x="640080" y="6437376"/>
+            <a:ext cx="10362895" cy="274320"/>
+          </a:xfrm>
+          <a:prstGeom prst="rect">
+            <a:avLst/>
+          </a:prstGeom>
+          <a:noFill/>
+        </p:spPr>
+        <p:txBody>
+          <a:bodyPr wrap="none">
+            <a:spAutoFit/>
+          </a:bodyPr>
+          <a:lstStyle/>
+          <a:p>
+            <a:r>
+              <a:rPr sz="1100">
+                <a:solidFill>
+                  <a:srgbClr val="5A6652"/>
+                </a:solidFill>
+                <a:latin typeface="Calibri"/>
+              </a:rPr>
+              <a:t>Website UNSIKA — Pertemuan 1 — Fondasi Web &amp; HTML</a:t>
+            </a:r>
+          </a:p>
+        </p:txBody>
+      </p:sp>
+      <p:sp>
+        <p:nvSpPr>
+          <p:cNvPr id="11" name="TextBox 10">
+            <a:extLst>
+              <a:ext uri="{FF2B5EF4-FFF2-40B4-BE49-F238E27FC236}">
+                <a16:creationId xmlns:a16="http://schemas.microsoft.com/office/drawing/2014/main" id="{08790FCA-205E-DE2B-5B03-B3F685028522}"/>
+              </a:ext>
+            </a:extLst>
+          </p:cNvPr>
+          <p:cNvSpPr txBox="1"/>
+          <p:nvPr/>
+        </p:nvSpPr>
+        <p:spPr>
+          <a:xfrm>
+            <a:off x="11185855" y="6437376"/>
+            <a:ext cx="457200" cy="274320"/>
+          </a:xfrm>
+          <a:prstGeom prst="rect">
+            <a:avLst/>
+          </a:prstGeom>
+          <a:noFill/>
+        </p:spPr>
+        <p:txBody>
+          <a:bodyPr wrap="none">
+            <a:spAutoFit/>
+          </a:bodyPr>
+          <a:lstStyle/>
+          <a:p>
+            <a:pPr algn="r"/>
+            <a:r>
+              <a:rPr sz="1100" b="1">
+                <a:solidFill>
+                  <a:srgbClr val="C9A66B"/>
+                </a:solidFill>
+                <a:latin typeface="Calibri"/>
+              </a:rPr>
+              <a:t>5</a:t>
+            </a:r>
+          </a:p>
+        </p:txBody>
+      </p:sp>
+      <p:pic>
+        <p:nvPicPr>
+          <p:cNvPr id="15" name="Picture 14">
+            <a:extLst>
+              <a:ext uri="{FF2B5EF4-FFF2-40B4-BE49-F238E27FC236}">
+                <a16:creationId xmlns:a16="http://schemas.microsoft.com/office/drawing/2014/main" id="{90AAE59F-8F73-2F57-D5B9-A0274F00150B}"/>
+              </a:ext>
+            </a:extLst>
+          </p:cNvPr>
+          <p:cNvPicPr>
+            <a:picLocks noChangeAspect="1"/>
+          </p:cNvPicPr>
+          <p:nvPr/>
+        </p:nvPicPr>
+        <p:blipFill>
+          <a:blip r:embed="rId2"/>
+          <a:stretch>
+            <a:fillRect/>
+          </a:stretch>
+        </p:blipFill>
+        <p:spPr>
+          <a:xfrm>
+            <a:off x="920007" y="1558298"/>
+            <a:ext cx="10351986" cy="4427658"/>
+          </a:xfrm>
+          <a:prstGeom prst="rect">
+            <a:avLst/>
+          </a:prstGeom>
+        </p:spPr>
+      </p:pic>
+    </p:spTree>
+    <p:extLst>
+      <p:ext uri="{BB962C8B-B14F-4D97-AF65-F5344CB8AC3E}">
+        <p14:creationId xmlns:p14="http://schemas.microsoft.com/office/powerpoint/2010/main" val="758636291"/>
+      </p:ext>
+    </p:extLst>
+  </p:cSld>
+  <p:clrMapOvr>
+    <a:masterClrMapping/>
+  </p:clrMapOvr>
+</p:sld>
+</file>
+
+<file path=ppt/slides/slide8.xml><?xml version="1.0" encoding="utf-8"?>
+<p:sld xmlns:a="http://schemas.openxmlformats.org/drawingml/2006/main" xmlns:r="http://schemas.openxmlformats.org/officeDocument/2006/relationships" xmlns:p="http://schemas.openxmlformats.org/presentationml/2006/main">
+  <p:cSld>
+    <p:spTree>
+      <p:nvGrpSpPr>
         <p:cNvPr id="1" name=""/>
         <p:cNvGrpSpPr/>
         <p:nvPr/>
@@ -9817,7 +10969,7 @@
         </p:nvSpPr>
         <p:spPr>
           <a:xfrm>
-            <a:off x="7071055" y="1417320"/>
+            <a:off x="7558887" y="2093977"/>
             <a:ext cx="4480560" cy="2194559"/>
           </a:xfrm>
           <a:prstGeom prst="roundRect">
@@ -9853,7 +11005,7 @@
           <a:p>
             <a:pPr algn="ctr"/>
             <a:r>
-              <a:rPr sz="1300">
+              <a:rPr sz="1300" dirty="0">
                 <a:solidFill>
                   <a:srgbClr val="DCEFD1"/>
                 </a:solidFill>
@@ -9864,7 +11016,7 @@
           </a:p>
           <a:p>
             <a:r>
-              <a:rPr sz="1300">
+              <a:rPr sz="1300" dirty="0">
                 <a:solidFill>
                   <a:srgbClr val="DCEFD1"/>
                 </a:solidFill>
@@ -9875,7 +11027,7 @@
           </a:p>
           <a:p>
             <a:r>
-              <a:rPr sz="1300">
+              <a:rPr sz="1300" dirty="0">
                 <a:solidFill>
                   <a:srgbClr val="DCEFD1"/>
                 </a:solidFill>
@@ -9886,7 +11038,7 @@
           </a:p>
           <a:p>
             <a:r>
-              <a:rPr sz="1300">
+              <a:rPr sz="1300" dirty="0">
                 <a:solidFill>
                   <a:srgbClr val="DCEFD1"/>
                 </a:solidFill>
@@ -9897,18 +11049,36 @@
           </a:p>
           <a:p>
             <a:r>
-              <a:rPr sz="1300">
+              <a:rPr sz="1300" dirty="0">
                 <a:solidFill>
                   <a:srgbClr val="DCEFD1"/>
                 </a:solidFill>
                 <a:latin typeface="Consolas"/>
               </a:rPr>
-              <a:t>&lt;title&gt;Judul Tab Browser&lt;/title&gt;</a:t>
-            </a:r>
-          </a:p>
-          <a:p>
-            <a:r>
-              <a:rPr sz="1300">
+              <a:t>&lt;title&gt;</a:t>
+            </a:r>
+            <a:r>
+              <a:rPr sz="1300" dirty="0" err="1">
+                <a:solidFill>
+                  <a:srgbClr val="DCEFD1"/>
+                </a:solidFill>
+                <a:latin typeface="Consolas"/>
+              </a:rPr>
+              <a:t>Judul</a:t>
+            </a:r>
+            <a:r>
+              <a:rPr sz="1300" dirty="0">
+                <a:solidFill>
+                  <a:srgbClr val="DCEFD1"/>
+                </a:solidFill>
+                <a:latin typeface="Consolas"/>
+              </a:rPr>
+              <a:t> Tab Browser&lt;/title&gt;</a:t>
+            </a:r>
+          </a:p>
+          <a:p>
+            <a:r>
+              <a:rPr sz="1300" dirty="0">
                 <a:solidFill>
                   <a:srgbClr val="DCEFD1"/>
                 </a:solidFill>
@@ -10041,7 +11211,7 @@
 </p:sld>
 </file>
 
-<file path=ppt/slides/slide8.xml><?xml version="1.0" encoding="utf-8"?>
+<file path=ppt/slides/slide9.xml><?xml version="1.0" encoding="utf-8"?>
 <p:sld xmlns:a="http://schemas.openxmlformats.org/drawingml/2006/main" xmlns:r="http://schemas.openxmlformats.org/officeDocument/2006/relationships" xmlns:p="http://schemas.openxmlformats.org/presentationml/2006/main">
   <p:cSld>
     <p:spTree>
@@ -10985,726 +12155,6 @@
 </p:sld>
 </file>
 
-<file path=ppt/slides/slide9.xml><?xml version="1.0" encoding="utf-8"?>
-<p:sld xmlns:a="http://schemas.openxmlformats.org/drawingml/2006/main" xmlns:r="http://schemas.openxmlformats.org/officeDocument/2006/relationships" xmlns:p="http://schemas.openxmlformats.org/presentationml/2006/main">
-  <p:cSld>
-    <p:spTree>
-      <p:nvGrpSpPr>
-        <p:cNvPr id="1" name=""/>
-        <p:cNvGrpSpPr/>
-        <p:nvPr/>
-      </p:nvGrpSpPr>
-      <p:grpSpPr>
-        <a:xfrm>
-          <a:off x="0" y="0"/>
-          <a:ext cx="0" cy="0"/>
-          <a:chOff x="0" y="0"/>
-          <a:chExt cx="0" cy="0"/>
-        </a:xfrm>
-      </p:grpSpPr>
-      <p:sp>
-        <p:nvSpPr>
-          <p:cNvPr id="2" name="Rectangle 1"/>
-          <p:cNvSpPr/>
-          <p:nvPr/>
-        </p:nvSpPr>
-        <p:spPr>
-          <a:xfrm>
-            <a:off x="0" y="0"/>
-            <a:ext cx="12191695" cy="6858000"/>
-          </a:xfrm>
-          <a:prstGeom prst="rect">
-            <a:avLst/>
-          </a:prstGeom>
-          <a:solidFill>
-            <a:srgbClr val="F6F3E7"/>
-          </a:solidFill>
-          <a:ln>
-            <a:noFill/>
-          </a:ln>
-          <a:effectLst/>
-        </p:spPr>
-        <p:style>
-          <a:lnRef idx="1">
-            <a:schemeClr val="accent1"/>
-          </a:lnRef>
-          <a:fillRef idx="3">
-            <a:schemeClr val="accent1"/>
-          </a:fillRef>
-          <a:effectRef idx="2">
-            <a:schemeClr val="accent1"/>
-          </a:effectRef>
-          <a:fontRef idx="minor">
-            <a:schemeClr val="lt1"/>
-          </a:fontRef>
-        </p:style>
-        <p:txBody>
-          <a:bodyPr rtlCol="0" anchor="ctr"/>
-          <a:lstStyle/>
-          <a:p>
-            <a:pPr algn="ctr"/>
-            <a:endParaRPr/>
-          </a:p>
-        </p:txBody>
-      </p:sp>
-      <p:sp>
-        <p:nvSpPr>
-          <p:cNvPr id="3" name="Rectangle 2"/>
-          <p:cNvSpPr/>
-          <p:nvPr/>
-        </p:nvSpPr>
-        <p:spPr>
-          <a:xfrm>
-            <a:off x="0" y="0"/>
-            <a:ext cx="12191695" cy="109728"/>
-          </a:xfrm>
-          <a:prstGeom prst="rect">
-            <a:avLst/>
-          </a:prstGeom>
-          <a:solidFill>
-            <a:srgbClr val="7C9473"/>
-          </a:solidFill>
-          <a:ln>
-            <a:noFill/>
-          </a:ln>
-          <a:effectLst/>
-        </p:spPr>
-        <p:style>
-          <a:lnRef idx="1">
-            <a:schemeClr val="accent1"/>
-          </a:lnRef>
-          <a:fillRef idx="3">
-            <a:schemeClr val="accent1"/>
-          </a:fillRef>
-          <a:effectRef idx="2">
-            <a:schemeClr val="accent1"/>
-          </a:effectRef>
-          <a:fontRef idx="minor">
-            <a:schemeClr val="lt1"/>
-          </a:fontRef>
-        </p:style>
-        <p:txBody>
-          <a:bodyPr rtlCol="0" anchor="ctr"/>
-          <a:lstStyle/>
-          <a:p>
-            <a:pPr algn="ctr"/>
-            <a:endParaRPr/>
-          </a:p>
-        </p:txBody>
-      </p:sp>
-      <p:sp>
-        <p:nvSpPr>
-          <p:cNvPr id="4" name="TextBox 3"/>
-          <p:cNvSpPr txBox="1"/>
-          <p:nvPr/>
-        </p:nvSpPr>
-        <p:spPr>
-          <a:xfrm>
-            <a:off x="640080" y="256032"/>
-            <a:ext cx="10911535" cy="320040"/>
-          </a:xfrm>
-          <a:prstGeom prst="rect">
-            <a:avLst/>
-          </a:prstGeom>
-          <a:noFill/>
-        </p:spPr>
-        <p:txBody>
-          <a:bodyPr wrap="none">
-            <a:spAutoFit/>
-          </a:bodyPr>
-          <a:lstStyle/>
-          <a:p>
-            <a:r>
-              <a:rPr sz="1300" b="1">
-                <a:solidFill>
-                  <a:srgbClr val="7C9473"/>
-                </a:solidFill>
-                <a:latin typeface="Calibri"/>
-              </a:rPr>
-              <a:t>TEORI — PERTEMUAN 1 — FONDASI WEB &amp; HTML</a:t>
-            </a:r>
-          </a:p>
-        </p:txBody>
-      </p:sp>
-      <p:sp>
-        <p:nvSpPr>
-          <p:cNvPr id="5" name="TextBox 4"/>
-          <p:cNvSpPr txBox="1"/>
-          <p:nvPr/>
-        </p:nvSpPr>
-        <p:spPr>
-          <a:xfrm>
-            <a:off x="640080" y="566928"/>
-            <a:ext cx="10911535" cy="914400"/>
-          </a:xfrm>
-          <a:prstGeom prst="rect">
-            <a:avLst/>
-          </a:prstGeom>
-          <a:noFill/>
-        </p:spPr>
-        <p:txBody>
-          <a:bodyPr wrap="square">
-            <a:spAutoFit/>
-          </a:bodyPr>
-          <a:lstStyle/>
-          <a:p>
-            <a:r>
-              <a:rPr sz="2700" b="1">
-                <a:solidFill>
-                  <a:srgbClr val="33422B"/>
-                </a:solidFill>
-                <a:latin typeface="Poppins"/>
-              </a:rPr>
-              <a:t>Tag umum untuk isi konten</a:t>
-            </a:r>
-          </a:p>
-        </p:txBody>
-      </p:sp>
-      <p:sp>
-        <p:nvSpPr>
-          <p:cNvPr id="6" name="Rectangle 5"/>
-          <p:cNvSpPr/>
-          <p:nvPr/>
-        </p:nvSpPr>
-        <p:spPr>
-          <a:xfrm>
-            <a:off x="640080" y="1188720"/>
-            <a:ext cx="1005840" cy="38100"/>
-          </a:xfrm>
-          <a:prstGeom prst="rect">
-            <a:avLst/>
-          </a:prstGeom>
-          <a:solidFill>
-            <a:srgbClr val="C9A66B"/>
-          </a:solidFill>
-          <a:ln>
-            <a:noFill/>
-          </a:ln>
-          <a:effectLst/>
-        </p:spPr>
-        <p:style>
-          <a:lnRef idx="1">
-            <a:schemeClr val="accent1"/>
-          </a:lnRef>
-          <a:fillRef idx="3">
-            <a:schemeClr val="accent1"/>
-          </a:fillRef>
-          <a:effectRef idx="2">
-            <a:schemeClr val="accent1"/>
-          </a:effectRef>
-          <a:fontRef idx="minor">
-            <a:schemeClr val="lt1"/>
-          </a:fontRef>
-        </p:style>
-        <p:txBody>
-          <a:bodyPr rtlCol="0" anchor="ctr"/>
-          <a:lstStyle/>
-          <a:p>
-            <a:pPr algn="ctr"/>
-            <a:endParaRPr/>
-          </a:p>
-        </p:txBody>
-      </p:sp>
-      <p:sp>
-        <p:nvSpPr>
-          <p:cNvPr id="7" name="TextBox 6"/>
-          <p:cNvSpPr txBox="1"/>
-          <p:nvPr/>
-        </p:nvSpPr>
-        <p:spPr>
-          <a:xfrm>
-            <a:off x="640080" y="1417320"/>
-            <a:ext cx="6766560" cy="2743200"/>
-          </a:xfrm>
-          <a:prstGeom prst="rect">
-            <a:avLst/>
-          </a:prstGeom>
-          <a:noFill/>
-        </p:spPr>
-        <p:txBody>
-          <a:bodyPr wrap="square">
-            <a:spAutoFit/>
-          </a:bodyPr>
-          <a:lstStyle/>
-          <a:p>
-            <a:pPr>
-              <a:spcAft>
-                <a:spcPts val="800"/>
-              </a:spcAft>
-            </a:pPr>
-            <a:r>
-              <a:rPr sz="1600" b="1">
-                <a:solidFill>
-                  <a:srgbClr val="7C9473"/>
-                </a:solidFill>
-              </a:rPr>
-              <a:t>●  </a:t>
-            </a:r>
-            <a:r>
-              <a:rPr sz="1600">
-                <a:solidFill>
-                  <a:srgbClr val="33422B"/>
-                </a:solidFill>
-                <a:latin typeface="Calibri"/>
-              </a:rPr>
-              <a:t>Heading: &lt;h1&gt; sampai &lt;h6&gt; — judul dan sub-judul, urut dari paling penting (h1) ke paling kecil.</a:t>
-            </a:r>
-          </a:p>
-          <a:p>
-            <a:pPr>
-              <a:spcAft>
-                <a:spcPts val="800"/>
-              </a:spcAft>
-            </a:pPr>
-            <a:r>
-              <a:rPr sz="1600" b="1">
-                <a:solidFill>
-                  <a:srgbClr val="7C9473"/>
-                </a:solidFill>
-              </a:rPr>
-              <a:t>●  </a:t>
-            </a:r>
-            <a:r>
-              <a:rPr sz="1600">
-                <a:solidFill>
-                  <a:srgbClr val="33422B"/>
-                </a:solidFill>
-                <a:latin typeface="Calibri"/>
-              </a:rPr>
-              <a:t>Paragraf: &lt;p&gt; — teks biasa.</a:t>
-            </a:r>
-          </a:p>
-          <a:p>
-            <a:pPr>
-              <a:spcAft>
-                <a:spcPts val="800"/>
-              </a:spcAft>
-            </a:pPr>
-            <a:r>
-              <a:rPr sz="1600" b="1">
-                <a:solidFill>
-                  <a:srgbClr val="7C9473"/>
-                </a:solidFill>
-              </a:rPr>
-              <a:t>●  </a:t>
-            </a:r>
-            <a:r>
-              <a:rPr sz="1600">
-                <a:solidFill>
-                  <a:srgbClr val="33422B"/>
-                </a:solidFill>
-                <a:latin typeface="Calibri"/>
-              </a:rPr>
-              <a:t>List: &lt;ul&gt; (list tanpa urutan) dan &lt;ol&gt; (list berurutan), isinya &lt;li&gt; per item.</a:t>
-            </a:r>
-          </a:p>
-          <a:p>
-            <a:pPr>
-              <a:spcAft>
-                <a:spcPts val="800"/>
-              </a:spcAft>
-            </a:pPr>
-            <a:r>
-              <a:rPr sz="1600" b="1">
-                <a:solidFill>
-                  <a:srgbClr val="7C9473"/>
-                </a:solidFill>
-              </a:rPr>
-              <a:t>●  </a:t>
-            </a:r>
-            <a:r>
-              <a:rPr sz="1600">
-                <a:solidFill>
-                  <a:srgbClr val="33422B"/>
-                </a:solidFill>
-                <a:latin typeface="Calibri"/>
-              </a:rPr>
-              <a:t>Gambar: &lt;img src="alamat-gambar.jpg" alt="deskripsi gambar"&gt;.</a:t>
-            </a:r>
-          </a:p>
-          <a:p>
-            <a:pPr>
-              <a:spcAft>
-                <a:spcPts val="800"/>
-              </a:spcAft>
-            </a:pPr>
-            <a:r>
-              <a:rPr sz="1600" b="1">
-                <a:solidFill>
-                  <a:srgbClr val="7C9473"/>
-                </a:solidFill>
-              </a:rPr>
-              <a:t>●  </a:t>
-            </a:r>
-            <a:r>
-              <a:rPr sz="1600">
-                <a:solidFill>
-                  <a:srgbClr val="33422B"/>
-                </a:solidFill>
-                <a:latin typeface="Calibri"/>
-              </a:rPr>
-              <a:t>Link: &lt;a href="alamat-tujuan"&gt;teks link&lt;/a&gt;.</a:t>
-            </a:r>
-          </a:p>
-        </p:txBody>
-      </p:sp>
-      <p:sp>
-        <p:nvSpPr>
-          <p:cNvPr id="8" name="Rounded Rectangle 7"/>
-          <p:cNvSpPr/>
-          <p:nvPr/>
-        </p:nvSpPr>
-        <p:spPr>
-          <a:xfrm>
-            <a:off x="7406640" y="1374648"/>
-            <a:ext cx="4480560" cy="2194559"/>
-          </a:xfrm>
-          <a:prstGeom prst="roundRect">
-            <a:avLst>
-              <a:gd name="adj" fmla="val 6000"/>
-            </a:avLst>
-          </a:prstGeom>
-          <a:solidFill>
-            <a:srgbClr val="22301C"/>
-          </a:solidFill>
-          <a:ln>
-            <a:noFill/>
-          </a:ln>
-          <a:effectLst/>
-        </p:spPr>
-        <p:style>
-          <a:lnRef idx="1">
-            <a:schemeClr val="accent1"/>
-          </a:lnRef>
-          <a:fillRef idx="3">
-            <a:schemeClr val="accent1"/>
-          </a:fillRef>
-          <a:effectRef idx="2">
-            <a:schemeClr val="accent1"/>
-          </a:effectRef>
-          <a:fontRef idx="minor">
-            <a:schemeClr val="lt1"/>
-          </a:fontRef>
-        </p:style>
-        <p:txBody>
-          <a:bodyPr wrap="square" lIns="182880" tIns="109728" rIns="137160" bIns="109728" rtlCol="0" anchor="ctr"/>
-          <a:lstStyle/>
-          <a:p>
-            <a:r>
-              <a:rPr sz="1300" dirty="0">
-                <a:solidFill>
-                  <a:srgbClr val="DCEFD1"/>
-                </a:solidFill>
-                <a:latin typeface="Consolas"/>
-              </a:rPr>
-              <a:t>&lt;h1&gt;</a:t>
-            </a:r>
-            <a:r>
-              <a:rPr sz="1300" dirty="0" err="1">
-                <a:solidFill>
-                  <a:srgbClr val="DCEFD1"/>
-                </a:solidFill>
-                <a:latin typeface="Consolas"/>
-              </a:rPr>
-              <a:t>Katalog</a:t>
-            </a:r>
-            <a:r>
-              <a:rPr sz="1300" dirty="0">
-                <a:solidFill>
-                  <a:srgbClr val="DCEFD1"/>
-                </a:solidFill>
-                <a:latin typeface="Consolas"/>
-              </a:rPr>
-              <a:t> UMKM Karawang&lt;/h1&gt;</a:t>
-            </a:r>
-          </a:p>
-          <a:p>
-            <a:r>
-              <a:rPr sz="1300" dirty="0">
-                <a:solidFill>
-                  <a:srgbClr val="DCEFD1"/>
-                </a:solidFill>
-                <a:latin typeface="Consolas"/>
-              </a:rPr>
-              <a:t>&lt;p&gt;</a:t>
-            </a:r>
-            <a:r>
-              <a:rPr sz="1300" dirty="0" err="1">
-                <a:solidFill>
-                  <a:srgbClr val="DCEFD1"/>
-                </a:solidFill>
-                <a:latin typeface="Consolas"/>
-              </a:rPr>
-              <a:t>Temukan</a:t>
-            </a:r>
-            <a:r>
-              <a:rPr sz="1300" dirty="0">
-                <a:solidFill>
-                  <a:srgbClr val="DCEFD1"/>
-                </a:solidFill>
-                <a:latin typeface="Consolas"/>
-              </a:rPr>
-              <a:t> </a:t>
-            </a:r>
-            <a:r>
-              <a:rPr sz="1300" dirty="0" err="1">
-                <a:solidFill>
-                  <a:srgbClr val="DCEFD1"/>
-                </a:solidFill>
-                <a:latin typeface="Consolas"/>
-              </a:rPr>
-              <a:t>usaha</a:t>
-            </a:r>
-            <a:r>
-              <a:rPr sz="1300" dirty="0">
-                <a:solidFill>
-                  <a:srgbClr val="DCEFD1"/>
-                </a:solidFill>
-                <a:latin typeface="Consolas"/>
-              </a:rPr>
-              <a:t> </a:t>
-            </a:r>
-            <a:r>
-              <a:rPr sz="1300" dirty="0" err="1">
-                <a:solidFill>
-                  <a:srgbClr val="DCEFD1"/>
-                </a:solidFill>
-                <a:latin typeface="Consolas"/>
-              </a:rPr>
-              <a:t>lokal</a:t>
-            </a:r>
-            <a:r>
-              <a:rPr sz="1300" dirty="0">
-                <a:solidFill>
-                  <a:srgbClr val="DCEFD1"/>
-                </a:solidFill>
-                <a:latin typeface="Consolas"/>
-              </a:rPr>
-              <a:t> </a:t>
-            </a:r>
-            <a:r>
-              <a:rPr sz="1300" dirty="0" err="1">
-                <a:solidFill>
-                  <a:srgbClr val="DCEFD1"/>
-                </a:solidFill>
-                <a:latin typeface="Consolas"/>
-              </a:rPr>
-              <a:t>terbaik</a:t>
-            </a:r>
-            <a:r>
-              <a:rPr sz="1300" dirty="0">
-                <a:solidFill>
-                  <a:srgbClr val="DCEFD1"/>
-                </a:solidFill>
-                <a:latin typeface="Consolas"/>
-              </a:rPr>
-              <a:t> di Karawang.&lt;/p&gt;</a:t>
-            </a:r>
-          </a:p>
-          <a:p>
-            <a:r>
-              <a:rPr sz="1300" dirty="0">
-                <a:solidFill>
-                  <a:srgbClr val="DCEFD1"/>
-                </a:solidFill>
-                <a:latin typeface="Consolas"/>
-              </a:rPr>
-              <a:t>&lt;ul&gt;</a:t>
-            </a:r>
-          </a:p>
-          <a:p>
-            <a:r>
-              <a:rPr sz="1300" dirty="0">
-                <a:solidFill>
-                  <a:srgbClr val="DCEFD1"/>
-                </a:solidFill>
-                <a:latin typeface="Consolas"/>
-              </a:rPr>
-              <a:t>&lt;li&gt;</a:t>
-            </a:r>
-            <a:r>
-              <a:rPr sz="1300" dirty="0" err="1">
-                <a:solidFill>
-                  <a:srgbClr val="DCEFD1"/>
-                </a:solidFill>
-                <a:latin typeface="Consolas"/>
-              </a:rPr>
-              <a:t>Kuliner</a:t>
-            </a:r>
-            <a:r>
-              <a:rPr sz="1300" dirty="0">
-                <a:solidFill>
-                  <a:srgbClr val="DCEFD1"/>
-                </a:solidFill>
-                <a:latin typeface="Consolas"/>
-              </a:rPr>
-              <a:t>&lt;/li&gt;</a:t>
-            </a:r>
-          </a:p>
-          <a:p>
-            <a:r>
-              <a:rPr sz="1300" dirty="0">
-                <a:solidFill>
-                  <a:srgbClr val="DCEFD1"/>
-                </a:solidFill>
-                <a:latin typeface="Consolas"/>
-              </a:rPr>
-              <a:t>&lt;li&gt;Fashion&lt;/li&gt;</a:t>
-            </a:r>
-          </a:p>
-          <a:p>
-            <a:r>
-              <a:rPr sz="1300" dirty="0">
-                <a:solidFill>
-                  <a:srgbClr val="DCEFD1"/>
-                </a:solidFill>
-                <a:latin typeface="Consolas"/>
-              </a:rPr>
-              <a:t>&lt;li&gt;</a:t>
-            </a:r>
-            <a:r>
-              <a:rPr sz="1300" dirty="0" err="1">
-                <a:solidFill>
-                  <a:srgbClr val="DCEFD1"/>
-                </a:solidFill>
-                <a:latin typeface="Consolas"/>
-              </a:rPr>
-              <a:t>Kerajinan</a:t>
-            </a:r>
-            <a:r>
-              <a:rPr sz="1300" dirty="0">
-                <a:solidFill>
-                  <a:srgbClr val="DCEFD1"/>
-                </a:solidFill>
-                <a:latin typeface="Consolas"/>
-              </a:rPr>
-              <a:t>&lt;/li&gt;</a:t>
-            </a:r>
-          </a:p>
-        </p:txBody>
-      </p:sp>
-      <p:sp>
-        <p:nvSpPr>
-          <p:cNvPr id="9" name="Rectangle 8"/>
-          <p:cNvSpPr/>
-          <p:nvPr/>
-        </p:nvSpPr>
-        <p:spPr>
-          <a:xfrm>
-            <a:off x="640080" y="6355080"/>
-            <a:ext cx="10911535" cy="12700"/>
-          </a:xfrm>
-          <a:prstGeom prst="rect">
-            <a:avLst/>
-          </a:prstGeom>
-          <a:solidFill>
-            <a:srgbClr val="C9A66B"/>
-          </a:solidFill>
-          <a:ln>
-            <a:noFill/>
-          </a:ln>
-          <a:effectLst/>
-        </p:spPr>
-        <p:style>
-          <a:lnRef idx="1">
-            <a:schemeClr val="accent1"/>
-          </a:lnRef>
-          <a:fillRef idx="3">
-            <a:schemeClr val="accent1"/>
-          </a:fillRef>
-          <a:effectRef idx="2">
-            <a:schemeClr val="accent1"/>
-          </a:effectRef>
-          <a:fontRef idx="minor">
-            <a:schemeClr val="lt1"/>
-          </a:fontRef>
-        </p:style>
-        <p:txBody>
-          <a:bodyPr rtlCol="0" anchor="ctr"/>
-          <a:lstStyle/>
-          <a:p>
-            <a:pPr algn="ctr"/>
-            <a:endParaRPr/>
-          </a:p>
-        </p:txBody>
-      </p:sp>
-      <p:sp>
-        <p:nvSpPr>
-          <p:cNvPr id="10" name="TextBox 9"/>
-          <p:cNvSpPr txBox="1"/>
-          <p:nvPr/>
-        </p:nvSpPr>
-        <p:spPr>
-          <a:xfrm>
-            <a:off x="640080" y="6437376"/>
-            <a:ext cx="10362895" cy="274320"/>
-          </a:xfrm>
-          <a:prstGeom prst="rect">
-            <a:avLst/>
-          </a:prstGeom>
-          <a:noFill/>
-        </p:spPr>
-        <p:txBody>
-          <a:bodyPr wrap="none">
-            <a:spAutoFit/>
-          </a:bodyPr>
-          <a:lstStyle/>
-          <a:p>
-            <a:r>
-              <a:rPr sz="1100">
-                <a:solidFill>
-                  <a:srgbClr val="5A6652"/>
-                </a:solidFill>
-                <a:latin typeface="Calibri"/>
-              </a:rPr>
-              <a:t>Website UNSIKA — Pertemuan 1 — Fondasi Web &amp; HTML</a:t>
-            </a:r>
-          </a:p>
-        </p:txBody>
-      </p:sp>
-      <p:sp>
-        <p:nvSpPr>
-          <p:cNvPr id="11" name="TextBox 10"/>
-          <p:cNvSpPr txBox="1"/>
-          <p:nvPr/>
-        </p:nvSpPr>
-        <p:spPr>
-          <a:xfrm>
-            <a:off x="11185855" y="6437376"/>
-            <a:ext cx="457200" cy="274320"/>
-          </a:xfrm>
-          <a:prstGeom prst="rect">
-            <a:avLst/>
-          </a:prstGeom>
-          <a:noFill/>
-        </p:spPr>
-        <p:txBody>
-          <a:bodyPr wrap="none">
-            <a:spAutoFit/>
-          </a:bodyPr>
-          <a:lstStyle/>
-          <a:p>
-            <a:pPr algn="r"/>
-            <a:r>
-              <a:rPr sz="1100" b="1">
-                <a:solidFill>
-                  <a:srgbClr val="C9A66B"/>
-                </a:solidFill>
-                <a:latin typeface="Calibri"/>
-              </a:rPr>
-              <a:t>8</a:t>
-            </a:r>
-          </a:p>
-        </p:txBody>
-      </p:sp>
-    </p:spTree>
-  </p:cSld>
-  <p:clrMapOvr>
-    <a:masterClrMapping/>
-  </p:clrMapOvr>
-</p:sld>
-</file>
-
 <file path=ppt/theme/theme1.xml><?xml version="1.0" encoding="utf-8"?>
 <a:theme xmlns:a="http://schemas.openxmlformats.org/drawingml/2006/main" name="Office Theme">
   <a:themeElements>

</xml_diff>